<commit_message>
Fixed presentation, maked optimization
</commit_message>
<xml_diff>
--- a/Labyrinthino3D.pptx
+++ b/Labyrinthino3D.pptx
@@ -7,7 +7,11 @@
   <p:sldIdLst>
     <p:sldId id="256" r:id="rId3"/>
     <p:sldId id="258" r:id="rId4"/>
-    <p:sldId id="257" r:id="rId5"/>
+    <p:sldId id="259" r:id="rId5"/>
+    <p:sldId id="263" r:id="rId6"/>
+    <p:sldId id="264" r:id="rId7"/>
+    <p:sldId id="257" r:id="rId8"/>
+    <p:sldId id="265" r:id="rId9"/>
   </p:sldIdLst>
   <p:sldSz cx="12192000" cy="6858000"/>
   <p:notesSz cx="6858000" cy="9144000"/>
@@ -114,7 +118,7 @@
             <a:srgbClr val="A4A3A4"/>
           </p15:clr>
         </p15:guide>
-        <p15:guide id="2" pos="3748" userDrawn="1">
+        <p15:guide id="2" pos="3782" userDrawn="1">
           <p15:clr>
             <a:srgbClr val="A4A3A4"/>
           </p15:clr>
@@ -2992,30 +2996,6 @@
           </a:p>
         </p:txBody>
       </p:sp>
-      <p:pic>
-        <p:nvPicPr>
-          <p:cNvPr id="4" name="Picture 3" descr="Logo"/>
-          <p:cNvPicPr>
-            <a:picLocks noChangeAspect="1"/>
-          </p:cNvPicPr>
-          <p:nvPr/>
-        </p:nvPicPr>
-        <p:blipFill>
-          <a:blip r:embed="rId1"/>
-          <a:stretch>
-            <a:fillRect/>
-          </a:stretch>
-        </p:blipFill>
-        <p:spPr>
-          <a:xfrm>
-            <a:off x="3694430" y="511175"/>
-            <a:ext cx="4802505" cy="3250565"/>
-          </a:xfrm>
-          <a:prstGeom prst="rect">
-            <a:avLst/>
-          </a:prstGeom>
-        </p:spPr>
-      </p:pic>
       <p:sp>
         <p:nvSpPr>
           <p:cNvPr id="3" name="Овал 2"/>
@@ -3193,44 +3173,22 @@
           <a:p>
             <a:pPr algn="ctr"/>
             <a:r>
-              <a:rPr lang="ru-RU" altLang="en-US" sz="3200" b="1">
-                <a:gradFill>
-                  <a:gsLst>
-                    <a:gs pos="0">
-                      <a:schemeClr val="accent1">
-                        <a:lumMod val="5000"/>
-                        <a:lumOff val="95000"/>
-                      </a:schemeClr>
-                    </a:gs>
-                    <a:gs pos="100000">
-                      <a:srgbClr val="479EFF"/>
-                    </a:gs>
-                  </a:gsLst>
-                  <a:lin ang="5400000" scaled="0"/>
-                </a:gradFill>
-                <a:latin typeface="Franklin Gothic Book" panose="020B0503020102020204" charset="0"/>
-                <a:cs typeface="Franklin Gothic Book" panose="020B0503020102020204" charset="0"/>
+              <a:rPr lang="ru-RU" altLang="en-US" sz="3200">
+                <a:solidFill>
+                  <a:srgbClr val="77B4FF"/>
+                </a:solidFill>
+                <a:latin typeface="Bahnschrift" panose="020B0502040204020203" charset="0"/>
+                <a:cs typeface="Bahnschrift" panose="020B0502040204020203" charset="0"/>
                 <a:sym typeface="+mn-ea"/>
               </a:rPr>
               <a:t>Оренбург</a:t>
             </a:r>
-            <a:endParaRPr lang="ru-RU" altLang="en-US" sz="3200" b="1">
-              <a:gradFill>
-                <a:gsLst>
-                  <a:gs pos="0">
-                    <a:schemeClr val="accent1">
-                      <a:lumMod val="5000"/>
-                      <a:lumOff val="95000"/>
-                    </a:schemeClr>
-                  </a:gs>
-                  <a:gs pos="100000">
-                    <a:srgbClr val="479EFF"/>
-                  </a:gs>
-                </a:gsLst>
-                <a:lin ang="5400000" scaled="0"/>
-              </a:gradFill>
-              <a:latin typeface="Franklin Gothic Book" panose="020B0503020102020204" charset="0"/>
-              <a:cs typeface="Franklin Gothic Book" panose="020B0503020102020204" charset="0"/>
+            <a:endParaRPr lang="ru-RU" altLang="en-US" sz="3200">
+              <a:solidFill>
+                <a:srgbClr val="77B4FF"/>
+              </a:solidFill>
+              <a:latin typeface="Bahnschrift" panose="020B0502040204020203" charset="0"/>
+              <a:cs typeface="Bahnschrift" panose="020B0502040204020203" charset="0"/>
               <a:sym typeface="+mn-ea"/>
             </a:endParaRPr>
           </a:p>
@@ -3423,6 +3381,722 @@
           </a:p>
         </p:txBody>
       </p:sp>
+      <p:sp>
+        <p:nvSpPr>
+          <p:cNvPr id="5" name="Скругленный прямоугольник 4"/>
+          <p:cNvSpPr/>
+          <p:nvPr/>
+        </p:nvSpPr>
+        <p:spPr>
+          <a:xfrm>
+            <a:off x="-6720205" y="1360170"/>
+            <a:ext cx="3754755" cy="4954905"/>
+          </a:xfrm>
+          <a:prstGeom prst="roundRect">
+            <a:avLst/>
+          </a:prstGeom>
+          <a:solidFill>
+            <a:srgbClr val="4040B2">
+              <a:alpha val="67000"/>
+            </a:srgbClr>
+          </a:solidFill>
+          <a:ln w="63500">
+            <a:gradFill>
+              <a:gsLst>
+                <a:gs pos="0">
+                  <a:srgbClr val="00A0FC"/>
+                </a:gs>
+                <a:gs pos="100000">
+                  <a:srgbClr val="1B00EA"/>
+                </a:gs>
+              </a:gsLst>
+              <a:lin ang="4740000" scaled="1"/>
+            </a:gradFill>
+          </a:ln>
+        </p:spPr>
+        <p:style>
+          <a:lnRef idx="2">
+            <a:schemeClr val="accent1">
+              <a:lumMod val="75000"/>
+            </a:schemeClr>
+          </a:lnRef>
+          <a:fillRef idx="1">
+            <a:schemeClr val="accent1"/>
+          </a:fillRef>
+          <a:effectRef idx="0">
+            <a:srgbClr val="FFFFFF"/>
+          </a:effectRef>
+          <a:fontRef idx="minor">
+            <a:schemeClr val="lt1"/>
+          </a:fontRef>
+        </p:style>
+        <p:txBody>
+          <a:bodyPr rtlCol="0" anchor="ctr"/>
+          <a:p>
+            <a:pPr algn="ctr"/>
+            <a:endParaRPr lang="ru-RU" altLang="en-US"/>
+          </a:p>
+        </p:txBody>
+      </p:sp>
+      <p:sp>
+        <p:nvSpPr>
+          <p:cNvPr id="2" name="Текстовое поле 1"/>
+          <p:cNvSpPr txBox="1"/>
+          <p:nvPr/>
+        </p:nvSpPr>
+        <p:spPr>
+          <a:xfrm>
+            <a:off x="-5952490" y="3607435"/>
+            <a:ext cx="2844165" cy="460375"/>
+          </a:xfrm>
+          <a:prstGeom prst="rect">
+            <a:avLst/>
+          </a:prstGeom>
+          <a:noFill/>
+        </p:spPr>
+        <p:txBody>
+          <a:bodyPr wrap="square" rtlCol="0">
+            <a:spAutoFit/>
+          </a:bodyPr>
+          <a:p>
+            <a:pPr algn="ctr"/>
+            <a:r>
+              <a:rPr lang="ru-RU" altLang="en-US" sz="2400">
+                <a:solidFill>
+                  <a:schemeClr val="bg1"/>
+                </a:solidFill>
+                <a:latin typeface="Franklin Gothic Medium" panose="020B0603020102020204" charset="0"/>
+                <a:cs typeface="Franklin Gothic Medium" panose="020B0603020102020204" charset="0"/>
+              </a:rPr>
+              <a:t>Жанр и аудитория</a:t>
+            </a:r>
+            <a:endParaRPr lang="ru-RU" altLang="en-US" sz="2400">
+              <a:solidFill>
+                <a:schemeClr val="bg1"/>
+              </a:solidFill>
+              <a:latin typeface="Franklin Gothic Medium" panose="020B0603020102020204" charset="0"/>
+              <a:cs typeface="Franklin Gothic Medium" panose="020B0603020102020204" charset="0"/>
+            </a:endParaRPr>
+          </a:p>
+        </p:txBody>
+      </p:sp>
+      <p:sp>
+        <p:nvSpPr>
+          <p:cNvPr id="9" name="Текстовое поле 8"/>
+          <p:cNvSpPr txBox="1"/>
+          <p:nvPr/>
+        </p:nvSpPr>
+        <p:spPr>
+          <a:xfrm>
+            <a:off x="-5952490" y="4862195"/>
+            <a:ext cx="2844165" cy="368300"/>
+          </a:xfrm>
+          <a:prstGeom prst="rect">
+            <a:avLst/>
+          </a:prstGeom>
+          <a:noFill/>
+        </p:spPr>
+        <p:txBody>
+          <a:bodyPr wrap="square" rtlCol="0">
+            <a:spAutoFit/>
+          </a:bodyPr>
+          <a:p>
+            <a:pPr algn="ctr"/>
+            <a:r>
+              <a:rPr lang="ru-RU" altLang="en-US">
+                <a:solidFill>
+                  <a:schemeClr val="bg1"/>
+                </a:solidFill>
+                <a:latin typeface="Franklin Gothic Medium" panose="020B0603020102020204" charset="0"/>
+                <a:cs typeface="Franklin Gothic Medium" panose="020B0603020102020204" charset="0"/>
+              </a:rPr>
+              <a:t>Основные механики</a:t>
+            </a:r>
+            <a:endParaRPr lang="ru-RU" altLang="en-US">
+              <a:solidFill>
+                <a:schemeClr val="bg1"/>
+              </a:solidFill>
+              <a:latin typeface="Franklin Gothic Medium" panose="020B0603020102020204" charset="0"/>
+              <a:cs typeface="Franklin Gothic Medium" panose="020B0603020102020204" charset="0"/>
+            </a:endParaRPr>
+          </a:p>
+        </p:txBody>
+      </p:sp>
+      <p:pic>
+        <p:nvPicPr>
+          <p:cNvPr id="10" name="Изображение 9" descr="image 5-1"/>
+          <p:cNvPicPr>
+            <a:picLocks noChangeAspect="1"/>
+          </p:cNvPicPr>
+          <p:nvPr/>
+        </p:nvPicPr>
+        <p:blipFill>
+          <a:blip r:embed="rId1"/>
+          <a:stretch>
+            <a:fillRect/>
+          </a:stretch>
+        </p:blipFill>
+        <p:spPr>
+          <a:xfrm>
+            <a:off x="14578965" y="1309370"/>
+            <a:ext cx="2787650" cy="2758440"/>
+          </a:xfrm>
+          <a:prstGeom prst="rect">
+            <a:avLst/>
+          </a:prstGeom>
+        </p:spPr>
+      </p:pic>
+      <p:sp>
+        <p:nvSpPr>
+          <p:cNvPr id="16" name="Скругленный прямоугольник 15"/>
+          <p:cNvSpPr/>
+          <p:nvPr/>
+        </p:nvSpPr>
+        <p:spPr>
+          <a:xfrm>
+            <a:off x="3401695" y="8287385"/>
+            <a:ext cx="5565775" cy="1257300"/>
+          </a:xfrm>
+          <a:prstGeom prst="roundRect">
+            <a:avLst/>
+          </a:prstGeom>
+          <a:solidFill>
+            <a:srgbClr val="4040B2"/>
+          </a:solidFill>
+          <a:ln w="63500">
+            <a:gradFill>
+              <a:gsLst>
+                <a:gs pos="0">
+                  <a:srgbClr val="00A0FC"/>
+                </a:gs>
+                <a:gs pos="100000">
+                  <a:srgbClr val="1B00EA"/>
+                </a:gs>
+              </a:gsLst>
+              <a:path path="rect">
+                <a:fillToRect l="50000" t="50000" r="50000" b="50000"/>
+              </a:path>
+              <a:tileRect/>
+            </a:gradFill>
+          </a:ln>
+        </p:spPr>
+        <p:style>
+          <a:lnRef idx="2">
+            <a:schemeClr val="accent1">
+              <a:lumMod val="75000"/>
+            </a:schemeClr>
+          </a:lnRef>
+          <a:fillRef idx="1">
+            <a:schemeClr val="accent1"/>
+          </a:fillRef>
+          <a:effectRef idx="0">
+            <a:srgbClr val="FFFFFF"/>
+          </a:effectRef>
+          <a:fontRef idx="minor">
+            <a:schemeClr val="lt1"/>
+          </a:fontRef>
+        </p:style>
+        <p:txBody>
+          <a:bodyPr rtlCol="0" anchor="ctr"/>
+          <a:p>
+            <a:pPr algn="ctr"/>
+            <a:endParaRPr lang="ru-RU" altLang="en-US"/>
+          </a:p>
+        </p:txBody>
+      </p:sp>
+      <p:sp>
+        <p:nvSpPr>
+          <p:cNvPr id="18" name="Текстовое поле 17"/>
+          <p:cNvSpPr txBox="1"/>
+          <p:nvPr/>
+        </p:nvSpPr>
+        <p:spPr>
+          <a:xfrm>
+            <a:off x="3575050" y="8368665"/>
+            <a:ext cx="5201920" cy="1042670"/>
+          </a:xfrm>
+          <a:prstGeom prst="rect">
+            <a:avLst/>
+          </a:prstGeom>
+          <a:noFill/>
+        </p:spPr>
+        <p:txBody>
+          <a:bodyPr wrap="square" rtlCol="0" anchor="ctr" anchorCtr="0">
+            <a:noAutofit/>
+          </a:bodyPr>
+          <a:p>
+            <a:pPr algn="l">
+              <a:lnSpc>
+                <a:spcPct val="100000"/>
+              </a:lnSpc>
+            </a:pPr>
+            <a:r>
+              <a:rPr lang="en-US" altLang="en-US" sz="2400">
+                <a:solidFill>
+                  <a:srgbClr val="9FE5FF"/>
+                </a:solidFill>
+                <a:latin typeface="Bahnschrift" panose="020B0502040204020203" charset="0"/>
+                <a:cs typeface="Bahnschrift" panose="020B0502040204020203" charset="0"/>
+                <a:sym typeface="+mn-ea"/>
+              </a:rPr>
+              <a:t>Жанр</a:t>
+            </a:r>
+            <a:r>
+              <a:rPr lang="en-US" altLang="ru-RU" sz="2400">
+                <a:solidFill>
+                  <a:srgbClr val="9FE5FF"/>
+                </a:solidFill>
+                <a:latin typeface="Bahnschrift" panose="020B0502040204020203" charset="0"/>
+                <a:cs typeface="Bahnschrift" panose="020B0502040204020203" charset="0"/>
+                <a:sym typeface="+mn-ea"/>
+              </a:rPr>
+              <a:t> </a:t>
+            </a:r>
+            <a:r>
+              <a:rPr lang="en-US" altLang="en-US" sz="2400">
+                <a:solidFill>
+                  <a:srgbClr val="9FE5FF"/>
+                </a:solidFill>
+                <a:latin typeface="Bahnschrift" panose="020B0502040204020203" charset="0"/>
+                <a:cs typeface="Bahnschrift" panose="020B0502040204020203" charset="0"/>
+                <a:sym typeface="+mn-ea"/>
+              </a:rPr>
+              <a:t>игры</a:t>
+            </a:r>
+            <a:endParaRPr lang="en-US" altLang="ru-RU" sz="2400">
+              <a:solidFill>
+                <a:srgbClr val="9FE5FF"/>
+              </a:solidFill>
+              <a:latin typeface="Bahnschrift" panose="020B0502040204020203" charset="0"/>
+              <a:cs typeface="Bahnschrift" panose="020B0502040204020203" charset="0"/>
+            </a:endParaRPr>
+          </a:p>
+          <a:p>
+            <a:pPr algn="ctr">
+              <a:lnSpc>
+                <a:spcPct val="100000"/>
+              </a:lnSpc>
+            </a:pPr>
+            <a:r>
+              <a:rPr lang="en-US" altLang="ru-RU" sz="2800">
+                <a:solidFill>
+                  <a:schemeClr val="bg1"/>
+                </a:solidFill>
+                <a:latin typeface="Franklin Gothic Medium" panose="020B0603020102020204" charset="0"/>
+                <a:cs typeface="Franklin Gothic Medium" panose="020B0603020102020204" charset="0"/>
+              </a:rPr>
+              <a:t>3D </a:t>
+            </a:r>
+            <a:r>
+              <a:rPr lang="en-US" altLang="en-US" sz="2800">
+                <a:solidFill>
+                  <a:schemeClr val="bg1"/>
+                </a:solidFill>
+                <a:latin typeface="Franklin Gothic Medium" panose="020B0603020102020204" charset="0"/>
+                <a:cs typeface="Franklin Gothic Medium" panose="020B0603020102020204" charset="0"/>
+              </a:rPr>
+              <a:t>головоломка</a:t>
+            </a:r>
+            <a:endParaRPr lang="ru-RU" altLang="en-US" sz="2800">
+              <a:solidFill>
+                <a:schemeClr val="bg1"/>
+              </a:solidFill>
+              <a:latin typeface="Franklin Gothic Medium" panose="020B0603020102020204" charset="0"/>
+              <a:cs typeface="Franklin Gothic Medium" panose="020B0603020102020204" charset="0"/>
+            </a:endParaRPr>
+          </a:p>
+        </p:txBody>
+      </p:sp>
+      <p:sp>
+        <p:nvSpPr>
+          <p:cNvPr id="21" name="Скругленный прямоугольник 20"/>
+          <p:cNvSpPr/>
+          <p:nvPr/>
+        </p:nvSpPr>
+        <p:spPr>
+          <a:xfrm>
+            <a:off x="3468370" y="17172305"/>
+            <a:ext cx="5565775" cy="1257300"/>
+          </a:xfrm>
+          <a:prstGeom prst="roundRect">
+            <a:avLst/>
+          </a:prstGeom>
+          <a:solidFill>
+            <a:srgbClr val="4040B2"/>
+          </a:solidFill>
+          <a:ln w="63500">
+            <a:gradFill>
+              <a:gsLst>
+                <a:gs pos="0">
+                  <a:srgbClr val="00A0FC"/>
+                </a:gs>
+                <a:gs pos="100000">
+                  <a:srgbClr val="1B00EA"/>
+                </a:gs>
+              </a:gsLst>
+              <a:path path="rect">
+                <a:fillToRect l="50000" t="50000" r="50000" b="50000"/>
+              </a:path>
+              <a:tileRect/>
+            </a:gradFill>
+          </a:ln>
+        </p:spPr>
+        <p:style>
+          <a:lnRef idx="2">
+            <a:schemeClr val="accent1">
+              <a:lumMod val="75000"/>
+            </a:schemeClr>
+          </a:lnRef>
+          <a:fillRef idx="1">
+            <a:schemeClr val="accent1"/>
+          </a:fillRef>
+          <a:effectRef idx="0">
+            <a:srgbClr val="FFFFFF"/>
+          </a:effectRef>
+          <a:fontRef idx="minor">
+            <a:schemeClr val="lt1"/>
+          </a:fontRef>
+        </p:style>
+        <p:txBody>
+          <a:bodyPr rtlCol="0" anchor="ctr"/>
+          <a:p>
+            <a:pPr algn="ctr"/>
+            <a:endParaRPr lang="ru-RU" altLang="en-US"/>
+          </a:p>
+        </p:txBody>
+      </p:sp>
+      <p:sp>
+        <p:nvSpPr>
+          <p:cNvPr id="22" name="Текстовое поле 21"/>
+          <p:cNvSpPr txBox="1"/>
+          <p:nvPr/>
+        </p:nvSpPr>
+        <p:spPr>
+          <a:xfrm>
+            <a:off x="3641725" y="17253585"/>
+            <a:ext cx="5201920" cy="1042670"/>
+          </a:xfrm>
+          <a:prstGeom prst="rect">
+            <a:avLst/>
+          </a:prstGeom>
+          <a:noFill/>
+        </p:spPr>
+        <p:txBody>
+          <a:bodyPr wrap="square" rtlCol="0" anchor="ctr" anchorCtr="0">
+            <a:noAutofit/>
+          </a:bodyPr>
+          <a:p>
+            <a:pPr algn="l">
+              <a:lnSpc>
+                <a:spcPct val="100000"/>
+              </a:lnSpc>
+            </a:pPr>
+            <a:r>
+              <a:rPr lang="ru-RU" altLang="en-US" sz="2400">
+                <a:solidFill>
+                  <a:srgbClr val="9FE5FF"/>
+                </a:solidFill>
+                <a:latin typeface="Bahnschrift" panose="020B0502040204020203" charset="0"/>
+                <a:cs typeface="Bahnschrift" panose="020B0502040204020203" charset="0"/>
+                <a:sym typeface="+mn-ea"/>
+              </a:rPr>
+              <a:t>Аудитория</a:t>
+            </a:r>
+            <a:endParaRPr lang="en-US" altLang="ru-RU" sz="2400">
+              <a:solidFill>
+                <a:srgbClr val="9FE5FF"/>
+              </a:solidFill>
+              <a:latin typeface="Bahnschrift" panose="020B0502040204020203" charset="0"/>
+              <a:cs typeface="Bahnschrift" panose="020B0502040204020203" charset="0"/>
+            </a:endParaRPr>
+          </a:p>
+          <a:p>
+            <a:pPr algn="ctr">
+              <a:lnSpc>
+                <a:spcPct val="100000"/>
+              </a:lnSpc>
+            </a:pPr>
+            <a:r>
+              <a:rPr lang="ru-RU" altLang="en-US" sz="2800">
+                <a:solidFill>
+                  <a:schemeClr val="bg1"/>
+                </a:solidFill>
+                <a:latin typeface="Franklin Gothic Medium" panose="020B0603020102020204" charset="0"/>
+                <a:cs typeface="Franklin Gothic Medium" panose="020B0603020102020204" charset="0"/>
+              </a:rPr>
+              <a:t>Л</a:t>
+            </a:r>
+            <a:r>
+              <a:rPr lang="en-US" altLang="en-US" sz="2800">
+                <a:solidFill>
+                  <a:schemeClr val="bg1"/>
+                </a:solidFill>
+                <a:latin typeface="Franklin Gothic Medium" panose="020B0603020102020204" charset="0"/>
+                <a:cs typeface="Franklin Gothic Medium" panose="020B0603020102020204" charset="0"/>
+              </a:rPr>
+              <a:t>юбители</a:t>
+            </a:r>
+            <a:r>
+              <a:rPr lang="en-US" altLang="ru-RU" sz="2800">
+                <a:solidFill>
+                  <a:schemeClr val="bg1"/>
+                </a:solidFill>
+                <a:latin typeface="Franklin Gothic Medium" panose="020B0603020102020204" charset="0"/>
+                <a:cs typeface="Franklin Gothic Medium" panose="020B0603020102020204" charset="0"/>
+              </a:rPr>
+              <a:t> </a:t>
+            </a:r>
+            <a:r>
+              <a:rPr lang="en-US" altLang="en-US" sz="2800">
+                <a:solidFill>
+                  <a:schemeClr val="bg1"/>
+                </a:solidFill>
+                <a:latin typeface="Franklin Gothic Medium" panose="020B0603020102020204" charset="0"/>
+                <a:cs typeface="Franklin Gothic Medium" panose="020B0603020102020204" charset="0"/>
+              </a:rPr>
+              <a:t>логических</a:t>
+            </a:r>
+            <a:r>
+              <a:rPr lang="en-US" altLang="ru-RU" sz="2800">
+                <a:solidFill>
+                  <a:schemeClr val="bg1"/>
+                </a:solidFill>
+                <a:latin typeface="Franklin Gothic Medium" panose="020B0603020102020204" charset="0"/>
+                <a:cs typeface="Franklin Gothic Medium" panose="020B0603020102020204" charset="0"/>
+              </a:rPr>
+              <a:t> </a:t>
+            </a:r>
+            <a:r>
+              <a:rPr lang="en-US" altLang="en-US" sz="2800">
+                <a:solidFill>
+                  <a:schemeClr val="bg1"/>
+                </a:solidFill>
+                <a:latin typeface="Franklin Gothic Medium" panose="020B0603020102020204" charset="0"/>
+                <a:cs typeface="Franklin Gothic Medium" panose="020B0603020102020204" charset="0"/>
+              </a:rPr>
+              <a:t>игр</a:t>
+            </a:r>
+            <a:r>
+              <a:rPr lang="en-US" altLang="ru-RU" sz="2800">
+                <a:solidFill>
+                  <a:schemeClr val="bg1"/>
+                </a:solidFill>
+                <a:latin typeface="Franklin Gothic Medium" panose="020B0603020102020204" charset="0"/>
+                <a:cs typeface="Franklin Gothic Medium" panose="020B0603020102020204" charset="0"/>
+              </a:rPr>
+              <a:t>.</a:t>
+            </a:r>
+            <a:endParaRPr lang="ru-RU" altLang="en-US" sz="2800">
+              <a:solidFill>
+                <a:schemeClr val="bg1"/>
+              </a:solidFill>
+              <a:latin typeface="Franklin Gothic Medium" panose="020B0603020102020204" charset="0"/>
+              <a:cs typeface="Franklin Gothic Medium" panose="020B0603020102020204" charset="0"/>
+            </a:endParaRPr>
+          </a:p>
+        </p:txBody>
+      </p:sp>
+      <p:sp>
+        <p:nvSpPr>
+          <p:cNvPr id="17" name="Овал 16"/>
+          <p:cNvSpPr/>
+          <p:nvPr/>
+        </p:nvSpPr>
+        <p:spPr>
+          <a:xfrm rot="180000">
+            <a:off x="11285855" y="13203555"/>
+            <a:ext cx="794385" cy="794385"/>
+          </a:xfrm>
+          <a:prstGeom prst="ellipse">
+            <a:avLst/>
+          </a:prstGeom>
+          <a:solidFill>
+            <a:srgbClr val="318DFF"/>
+          </a:solidFill>
+          <a:ln>
+            <a:noFill/>
+          </a:ln>
+        </p:spPr>
+        <p:style>
+          <a:lnRef idx="2">
+            <a:schemeClr val="accent1">
+              <a:lumMod val="75000"/>
+            </a:schemeClr>
+          </a:lnRef>
+          <a:fillRef idx="1">
+            <a:schemeClr val="accent1"/>
+          </a:fillRef>
+          <a:effectRef idx="0">
+            <a:srgbClr val="FFFFFF"/>
+          </a:effectRef>
+          <a:fontRef idx="minor">
+            <a:schemeClr val="lt1"/>
+          </a:fontRef>
+        </p:style>
+        <p:txBody>
+          <a:bodyPr rtlCol="0" anchor="ctr"/>
+          <a:p>
+            <a:pPr algn="ctr"/>
+            <a:endParaRPr lang="ru-RU" altLang="en-US"/>
+          </a:p>
+        </p:txBody>
+      </p:sp>
+      <p:sp>
+        <p:nvSpPr>
+          <p:cNvPr id="19" name="Текстовое поле 18"/>
+          <p:cNvSpPr txBox="1"/>
+          <p:nvPr/>
+        </p:nvSpPr>
+        <p:spPr>
+          <a:xfrm rot="180000">
+            <a:off x="11285220" y="13202920"/>
+            <a:ext cx="794385" cy="795655"/>
+          </a:xfrm>
+          <a:prstGeom prst="rect">
+            <a:avLst/>
+          </a:prstGeom>
+          <a:noFill/>
+        </p:spPr>
+        <p:txBody>
+          <a:bodyPr wrap="square" rtlCol="0" anchor="ctr" anchorCtr="0">
+            <a:noAutofit/>
+          </a:bodyPr>
+          <a:p>
+            <a:pPr algn="ctr"/>
+            <a:r>
+              <a:rPr lang="ru-RU" altLang="en-US" sz="2800">
+                <a:solidFill>
+                  <a:schemeClr val="bg1"/>
+                </a:solidFill>
+                <a:latin typeface="Bahnschrift" panose="020B0502040204020203" charset="0"/>
+                <a:cs typeface="Bahnschrift" panose="020B0502040204020203" charset="0"/>
+              </a:rPr>
+              <a:t>8+</a:t>
+            </a:r>
+            <a:endParaRPr lang="ru-RU" altLang="en-US" sz="2800">
+              <a:solidFill>
+                <a:schemeClr val="bg1"/>
+              </a:solidFill>
+              <a:latin typeface="Bahnschrift" panose="020B0502040204020203" charset="0"/>
+              <a:cs typeface="Bahnschrift" panose="020B0502040204020203" charset="0"/>
+            </a:endParaRPr>
+          </a:p>
+        </p:txBody>
+      </p:sp>
+      <p:sp>
+        <p:nvSpPr>
+          <p:cNvPr id="23" name="Овал 22"/>
+          <p:cNvSpPr/>
+          <p:nvPr/>
+        </p:nvSpPr>
+        <p:spPr>
+          <a:xfrm rot="180000">
+            <a:off x="1366520" y="13191490"/>
+            <a:ext cx="353695" cy="353695"/>
+          </a:xfrm>
+          <a:prstGeom prst="ellipse">
+            <a:avLst/>
+          </a:prstGeom>
+          <a:solidFill>
+            <a:srgbClr val="3F31FF"/>
+          </a:solidFill>
+          <a:ln>
+            <a:noFill/>
+          </a:ln>
+        </p:spPr>
+        <p:style>
+          <a:lnRef idx="2">
+            <a:schemeClr val="accent1">
+              <a:lumMod val="75000"/>
+            </a:schemeClr>
+          </a:lnRef>
+          <a:fillRef idx="1">
+            <a:schemeClr val="accent1"/>
+          </a:fillRef>
+          <a:effectRef idx="0">
+            <a:srgbClr val="FFFFFF"/>
+          </a:effectRef>
+          <a:fontRef idx="minor">
+            <a:schemeClr val="lt1"/>
+          </a:fontRef>
+        </p:style>
+        <p:txBody>
+          <a:bodyPr rtlCol="0" anchor="ctr"/>
+          <a:p>
+            <a:pPr algn="ctr"/>
+            <a:endParaRPr lang="ru-RU" altLang="en-US"/>
+          </a:p>
+        </p:txBody>
+      </p:sp>
+      <p:sp>
+        <p:nvSpPr>
+          <p:cNvPr id="25" name="Овал 24"/>
+          <p:cNvSpPr/>
+          <p:nvPr/>
+        </p:nvSpPr>
+        <p:spPr>
+          <a:xfrm rot="180000">
+            <a:off x="8414385" y="9460865"/>
+            <a:ext cx="353695" cy="353695"/>
+          </a:xfrm>
+          <a:prstGeom prst="ellipse">
+            <a:avLst/>
+          </a:prstGeom>
+          <a:solidFill>
+            <a:srgbClr val="3F31FF"/>
+          </a:solidFill>
+          <a:ln>
+            <a:noFill/>
+          </a:ln>
+        </p:spPr>
+        <p:style>
+          <a:lnRef idx="2">
+            <a:schemeClr val="accent1">
+              <a:lumMod val="75000"/>
+            </a:schemeClr>
+          </a:lnRef>
+          <a:fillRef idx="1">
+            <a:schemeClr val="accent1"/>
+          </a:fillRef>
+          <a:effectRef idx="0">
+            <a:srgbClr val="FFFFFF"/>
+          </a:effectRef>
+          <a:fontRef idx="minor">
+            <a:schemeClr val="lt1"/>
+          </a:fontRef>
+        </p:style>
+        <p:txBody>
+          <a:bodyPr rtlCol="0" anchor="ctr"/>
+          <a:p>
+            <a:pPr algn="ctr"/>
+            <a:endParaRPr lang="ru-RU" altLang="en-US"/>
+          </a:p>
+        </p:txBody>
+      </p:sp>
+      <p:pic>
+        <p:nvPicPr>
+          <p:cNvPr id="20" name="Изображение 19" descr="MyLogo"/>
+          <p:cNvPicPr>
+            <a:picLocks noChangeAspect="1"/>
+          </p:cNvPicPr>
+          <p:nvPr/>
+        </p:nvPicPr>
+        <p:blipFill>
+          <a:blip r:embed="rId2"/>
+          <a:stretch>
+            <a:fillRect/>
+          </a:stretch>
+        </p:blipFill>
+        <p:spPr>
+          <a:xfrm>
+            <a:off x="4180205" y="147955"/>
+            <a:ext cx="3832225" cy="3832225"/>
+          </a:xfrm>
+          <a:prstGeom prst="rect">
+            <a:avLst/>
+          </a:prstGeom>
+        </p:spPr>
+      </p:pic>
     </p:spTree>
   </p:cSld>
   <p:clrMapOvr>
@@ -3513,30 +4187,6 @@
           </a:p>
         </p:txBody>
       </p:sp>
-      <p:pic>
-        <p:nvPicPr>
-          <p:cNvPr id="4" name="Picture 3" descr="Logo"/>
-          <p:cNvPicPr>
-            <a:picLocks noChangeAspect="1"/>
-          </p:cNvPicPr>
-          <p:nvPr/>
-        </p:nvPicPr>
-        <p:blipFill>
-          <a:blip r:embed="rId1"/>
-          <a:stretch>
-            <a:fillRect/>
-          </a:stretch>
-        </p:blipFill>
-        <p:spPr>
-          <a:xfrm>
-            <a:off x="3602990" y="-6553200"/>
-            <a:ext cx="4802505" cy="3250565"/>
-          </a:xfrm>
-          <a:prstGeom prst="rect">
-            <a:avLst/>
-          </a:prstGeom>
-        </p:spPr>
-      </p:pic>
       <p:sp>
         <p:nvSpPr>
           <p:cNvPr id="3" name="Овал 2"/>
@@ -4009,7 +4659,7 @@
         </p:nvSpPr>
         <p:spPr>
           <a:xfrm>
-            <a:off x="142875" y="2758440"/>
+            <a:off x="59690" y="2758440"/>
             <a:ext cx="2844165" cy="460375"/>
           </a:xfrm>
           <a:prstGeom prst="rect">
@@ -4022,7 +4672,7 @@
             <a:spAutoFit/>
           </a:bodyPr>
           <a:p>
-            <a:pPr algn="ctr"/>
+            <a:pPr algn="r"/>
             <a:r>
               <a:rPr lang="ru-RU" altLang="en-US" sz="2400">
                 <a:solidFill>
@@ -4051,7 +4701,7 @@
         </p:nvSpPr>
         <p:spPr>
           <a:xfrm>
-            <a:off x="142875" y="4013200"/>
+            <a:off x="59690" y="4013200"/>
             <a:ext cx="2844165" cy="368300"/>
           </a:xfrm>
           <a:prstGeom prst="rect">
@@ -4064,7 +4714,7 @@
             <a:spAutoFit/>
           </a:bodyPr>
           <a:p>
-            <a:pPr algn="ctr"/>
+            <a:pPr algn="r"/>
             <a:r>
               <a:rPr lang="ru-RU" altLang="en-US">
                 <a:solidFill>
@@ -4094,7 +4744,7 @@
           <p:nvPr/>
         </p:nvPicPr>
         <p:blipFill>
-          <a:blip r:embed="rId2"/>
+          <a:blip r:embed="rId1"/>
           <a:stretch>
             <a:fillRect/>
           </a:stretch>
@@ -4117,8 +4767,8 @@
         </p:nvSpPr>
         <p:spPr>
           <a:xfrm>
-            <a:off x="3693795" y="1605280"/>
-            <a:ext cx="5565775" cy="949960"/>
+            <a:off x="3693795" y="1385570"/>
+            <a:ext cx="5565775" cy="1257300"/>
           </a:xfrm>
           <a:prstGeom prst="roundRect">
             <a:avLst/>
@@ -4175,8 +4825,8 @@
         </p:nvSpPr>
         <p:spPr>
           <a:xfrm>
-            <a:off x="3867150" y="1686560"/>
-            <a:ext cx="5201920" cy="787400"/>
+            <a:off x="3867150" y="1466850"/>
+            <a:ext cx="5201920" cy="1042670"/>
           </a:xfrm>
           <a:prstGeom prst="rect">
             <a:avLst/>
@@ -4198,8 +4848,8 @@
                 <a:solidFill>
                   <a:srgbClr val="9FE5FF"/>
                 </a:solidFill>
-                <a:latin typeface="Franklin Gothic Book" panose="020B0503020102020204" charset="0"/>
-                <a:cs typeface="Franklin Gothic Book" panose="020B0503020102020204" charset="0"/>
+                <a:latin typeface="Bahnschrift" panose="020B0502040204020203" charset="0"/>
+                <a:cs typeface="Bahnschrift" panose="020B0502040204020203" charset="0"/>
                 <a:sym typeface="+mn-ea"/>
               </a:rPr>
               <a:t>Жанр</a:t>
@@ -4209,8 +4859,8 @@
                 <a:solidFill>
                   <a:srgbClr val="9FE5FF"/>
                 </a:solidFill>
-                <a:latin typeface="Franklin Gothic Book" panose="020B0503020102020204" charset="0"/>
-                <a:cs typeface="Franklin Gothic Book" panose="020B0503020102020204" charset="0"/>
+                <a:latin typeface="Bahnschrift" panose="020B0502040204020203" charset="0"/>
+                <a:cs typeface="Bahnschrift" panose="020B0502040204020203" charset="0"/>
                 <a:sym typeface="+mn-ea"/>
               </a:rPr>
               <a:t> </a:t>
@@ -4220,8 +4870,8 @@
                 <a:solidFill>
                   <a:srgbClr val="9FE5FF"/>
                 </a:solidFill>
-                <a:latin typeface="Franklin Gothic Book" panose="020B0503020102020204" charset="0"/>
-                <a:cs typeface="Franklin Gothic Book" panose="020B0503020102020204" charset="0"/>
+                <a:latin typeface="Bahnschrift" panose="020B0502040204020203" charset="0"/>
+                <a:cs typeface="Bahnschrift" panose="020B0502040204020203" charset="0"/>
                 <a:sym typeface="+mn-ea"/>
               </a:rPr>
               <a:t>игры</a:t>
@@ -4230,8 +4880,8 @@
               <a:solidFill>
                 <a:srgbClr val="9FE5FF"/>
               </a:solidFill>
-              <a:latin typeface="Franklin Gothic Book" panose="020B0503020102020204" charset="0"/>
-              <a:cs typeface="Franklin Gothic Book" panose="020B0503020102020204" charset="0"/>
+              <a:latin typeface="Bahnschrift" panose="020B0502040204020203" charset="0"/>
+              <a:cs typeface="Bahnschrift" panose="020B0502040204020203" charset="0"/>
             </a:endParaRPr>
           </a:p>
           <a:p>
@@ -4279,7 +4929,7 @@
         <p:spPr>
           <a:xfrm>
             <a:off x="3760470" y="3124200"/>
-            <a:ext cx="5565775" cy="949960"/>
+            <a:ext cx="5565775" cy="1257300"/>
           </a:xfrm>
           <a:prstGeom prst="roundRect">
             <a:avLst/>
@@ -4337,7 +4987,7 @@
         <p:spPr>
           <a:xfrm>
             <a:off x="3933825" y="3205480"/>
-            <a:ext cx="5201920" cy="787400"/>
+            <a:ext cx="5201920" cy="1042670"/>
           </a:xfrm>
           <a:prstGeom prst="rect">
             <a:avLst/>
@@ -4359,8 +5009,8 @@
                 <a:solidFill>
                   <a:srgbClr val="9FE5FF"/>
                 </a:solidFill>
-                <a:latin typeface="Franklin Gothic Book" panose="020B0503020102020204" charset="0"/>
-                <a:cs typeface="Franklin Gothic Book" panose="020B0503020102020204" charset="0"/>
+                <a:latin typeface="Bahnschrift" panose="020B0502040204020203" charset="0"/>
+                <a:cs typeface="Bahnschrift" panose="020B0502040204020203" charset="0"/>
                 <a:sym typeface="+mn-ea"/>
               </a:rPr>
               <a:t>Аудитория</a:t>
@@ -4369,8 +5019,8 @@
               <a:solidFill>
                 <a:srgbClr val="9FE5FF"/>
               </a:solidFill>
-              <a:latin typeface="Franklin Gothic Book" panose="020B0503020102020204" charset="0"/>
-              <a:cs typeface="Franklin Gothic Book" panose="020B0503020102020204" charset="0"/>
+              <a:latin typeface="Bahnschrift" panose="020B0502040204020203" charset="0"/>
+              <a:cs typeface="Bahnschrift" panose="020B0502040204020203" charset="0"/>
             </a:endParaRPr>
           </a:p>
           <a:p>
@@ -4380,14 +5030,14 @@
               </a:lnSpc>
             </a:pPr>
             <a:r>
-              <a:rPr lang="en-US" altLang="ru-RU" sz="2800">
+              <a:rPr lang="ru-RU" altLang="en-US" sz="2800">
                 <a:solidFill>
                   <a:schemeClr val="bg1"/>
                 </a:solidFill>
                 <a:latin typeface="Franklin Gothic Medium" panose="020B0603020102020204" charset="0"/>
                 <a:cs typeface="Franklin Gothic Medium" panose="020B0603020102020204" charset="0"/>
               </a:rPr>
-              <a:t>8+, </a:t>
+              <a:t>Л</a:t>
             </a:r>
             <a:r>
               <a:rPr lang="en-US" altLang="en-US" sz="2800">
@@ -4397,7 +5047,7 @@
                 <a:latin typeface="Franklin Gothic Medium" panose="020B0603020102020204" charset="0"/>
                 <a:cs typeface="Franklin Gothic Medium" panose="020B0603020102020204" charset="0"/>
               </a:rPr>
-              <a:t>любители</a:t>
+              <a:t>юбители</a:t>
             </a:r>
             <a:r>
               <a:rPr lang="en-US" altLang="ru-RU" sz="2800">
@@ -4459,6 +5109,298 @@
           </a:p>
         </p:txBody>
       </p:sp>
+      <p:sp>
+        <p:nvSpPr>
+          <p:cNvPr id="17" name="Овал 16"/>
+          <p:cNvSpPr/>
+          <p:nvPr/>
+        </p:nvSpPr>
+        <p:spPr>
+          <a:xfrm rot="180000">
+            <a:off x="9939655" y="4150360"/>
+            <a:ext cx="794385" cy="794385"/>
+          </a:xfrm>
+          <a:prstGeom prst="ellipse">
+            <a:avLst/>
+          </a:prstGeom>
+          <a:solidFill>
+            <a:srgbClr val="318DFF"/>
+          </a:solidFill>
+          <a:ln>
+            <a:noFill/>
+          </a:ln>
+        </p:spPr>
+        <p:style>
+          <a:lnRef idx="2">
+            <a:schemeClr val="accent1">
+              <a:lumMod val="75000"/>
+            </a:schemeClr>
+          </a:lnRef>
+          <a:fillRef idx="1">
+            <a:schemeClr val="accent1"/>
+          </a:fillRef>
+          <a:effectRef idx="0">
+            <a:srgbClr val="FFFFFF"/>
+          </a:effectRef>
+          <a:fontRef idx="minor">
+            <a:schemeClr val="lt1"/>
+          </a:fontRef>
+        </p:style>
+        <p:txBody>
+          <a:bodyPr rtlCol="0" anchor="ctr"/>
+          <a:p>
+            <a:pPr algn="ctr"/>
+            <a:endParaRPr lang="ru-RU" altLang="en-US"/>
+          </a:p>
+        </p:txBody>
+      </p:sp>
+      <p:sp>
+        <p:nvSpPr>
+          <p:cNvPr id="19" name="Текстовое поле 18"/>
+          <p:cNvSpPr txBox="1"/>
+          <p:nvPr/>
+        </p:nvSpPr>
+        <p:spPr>
+          <a:xfrm rot="180000">
+            <a:off x="9939020" y="4149725"/>
+            <a:ext cx="794385" cy="795655"/>
+          </a:xfrm>
+          <a:prstGeom prst="rect">
+            <a:avLst/>
+          </a:prstGeom>
+          <a:noFill/>
+        </p:spPr>
+        <p:txBody>
+          <a:bodyPr wrap="square" rtlCol="0" anchor="ctr" anchorCtr="0">
+            <a:noAutofit/>
+          </a:bodyPr>
+          <a:p>
+            <a:pPr algn="ctr"/>
+            <a:r>
+              <a:rPr lang="ru-RU" altLang="en-US" sz="2800">
+                <a:solidFill>
+                  <a:schemeClr val="bg1"/>
+                </a:solidFill>
+                <a:latin typeface="Bahnschrift" panose="020B0502040204020203" charset="0"/>
+                <a:cs typeface="Bahnschrift" panose="020B0502040204020203" charset="0"/>
+              </a:rPr>
+              <a:t>8+</a:t>
+            </a:r>
+            <a:endParaRPr lang="ru-RU" altLang="en-US" sz="2800">
+              <a:solidFill>
+                <a:schemeClr val="bg1"/>
+              </a:solidFill>
+              <a:latin typeface="Bahnschrift" panose="020B0502040204020203" charset="0"/>
+              <a:cs typeface="Bahnschrift" panose="020B0502040204020203" charset="0"/>
+            </a:endParaRPr>
+          </a:p>
+        </p:txBody>
+      </p:sp>
+      <p:sp>
+        <p:nvSpPr>
+          <p:cNvPr id="23" name="Овал 22"/>
+          <p:cNvSpPr/>
+          <p:nvPr/>
+        </p:nvSpPr>
+        <p:spPr>
+          <a:xfrm rot="180000">
+            <a:off x="3331210" y="4603115"/>
+            <a:ext cx="353695" cy="353695"/>
+          </a:xfrm>
+          <a:prstGeom prst="ellipse">
+            <a:avLst/>
+          </a:prstGeom>
+          <a:solidFill>
+            <a:srgbClr val="3F31FF"/>
+          </a:solidFill>
+          <a:ln>
+            <a:noFill/>
+          </a:ln>
+        </p:spPr>
+        <p:style>
+          <a:lnRef idx="2">
+            <a:schemeClr val="accent1">
+              <a:lumMod val="75000"/>
+            </a:schemeClr>
+          </a:lnRef>
+          <a:fillRef idx="1">
+            <a:schemeClr val="accent1"/>
+          </a:fillRef>
+          <a:effectRef idx="0">
+            <a:srgbClr val="FFFFFF"/>
+          </a:effectRef>
+          <a:fontRef idx="minor">
+            <a:schemeClr val="lt1"/>
+          </a:fontRef>
+        </p:style>
+        <p:txBody>
+          <a:bodyPr rtlCol="0" anchor="ctr"/>
+          <a:p>
+            <a:pPr algn="ctr"/>
+            <a:endParaRPr lang="ru-RU" altLang="en-US"/>
+          </a:p>
+        </p:txBody>
+      </p:sp>
+      <p:sp>
+        <p:nvSpPr>
+          <p:cNvPr id="25" name="Овал 24"/>
+          <p:cNvSpPr/>
+          <p:nvPr/>
+        </p:nvSpPr>
+        <p:spPr>
+          <a:xfrm rot="180000">
+            <a:off x="8414385" y="408305"/>
+            <a:ext cx="353695" cy="353695"/>
+          </a:xfrm>
+          <a:prstGeom prst="ellipse">
+            <a:avLst/>
+          </a:prstGeom>
+          <a:solidFill>
+            <a:srgbClr val="3F31FF"/>
+          </a:solidFill>
+          <a:ln>
+            <a:noFill/>
+          </a:ln>
+        </p:spPr>
+        <p:style>
+          <a:lnRef idx="2">
+            <a:schemeClr val="accent1">
+              <a:lumMod val="75000"/>
+            </a:schemeClr>
+          </a:lnRef>
+          <a:fillRef idx="1">
+            <a:schemeClr val="accent1"/>
+          </a:fillRef>
+          <a:effectRef idx="0">
+            <a:srgbClr val="FFFFFF"/>
+          </a:effectRef>
+          <a:fontRef idx="minor">
+            <a:schemeClr val="lt1"/>
+          </a:fontRef>
+        </p:style>
+        <p:txBody>
+          <a:bodyPr rtlCol="0" anchor="ctr"/>
+          <a:p>
+            <a:pPr algn="ctr"/>
+            <a:endParaRPr lang="ru-RU" altLang="en-US"/>
+          </a:p>
+        </p:txBody>
+      </p:sp>
+      <p:sp>
+        <p:nvSpPr>
+          <p:cNvPr id="26" name="Текстовое поле 25"/>
+          <p:cNvSpPr txBox="1"/>
+          <p:nvPr/>
+        </p:nvSpPr>
+        <p:spPr>
+          <a:xfrm>
+            <a:off x="-4422140" y="4128135"/>
+            <a:ext cx="2993390" cy="368300"/>
+          </a:xfrm>
+          <a:prstGeom prst="rect">
+            <a:avLst/>
+          </a:prstGeom>
+          <a:noFill/>
+        </p:spPr>
+        <p:txBody>
+          <a:bodyPr wrap="square" rtlCol="0">
+            <a:spAutoFit/>
+          </a:bodyPr>
+          <a:p>
+            <a:pPr algn="ctr"/>
+            <a:r>
+              <a:rPr lang="ru-RU" altLang="en-US">
+                <a:solidFill>
+                  <a:schemeClr val="bg1"/>
+                </a:solidFill>
+                <a:latin typeface="Franklin Gothic Medium" panose="020B0603020102020204" charset="0"/>
+                <a:cs typeface="Franklin Gothic Medium" panose="020B0603020102020204" charset="0"/>
+              </a:rPr>
+              <a:t>Водная комната</a:t>
+            </a:r>
+            <a:endParaRPr lang="ru-RU" altLang="en-US">
+              <a:solidFill>
+                <a:schemeClr val="bg1"/>
+              </a:solidFill>
+              <a:latin typeface="Franklin Gothic Medium" panose="020B0603020102020204" charset="0"/>
+              <a:cs typeface="Franklin Gothic Medium" panose="020B0603020102020204" charset="0"/>
+            </a:endParaRPr>
+          </a:p>
+        </p:txBody>
+      </p:sp>
+      <p:pic>
+        <p:nvPicPr>
+          <p:cNvPr id="32" name="Изображение 31" descr="image 5"/>
+          <p:cNvPicPr>
+            <a:picLocks noChangeAspect="1"/>
+          </p:cNvPicPr>
+          <p:nvPr/>
+        </p:nvPicPr>
+        <p:blipFill>
+          <a:blip r:embed="rId2"/>
+          <a:stretch>
+            <a:fillRect/>
+          </a:stretch>
+        </p:blipFill>
+        <p:spPr>
+          <a:xfrm>
+            <a:off x="12417425" y="9042400"/>
+            <a:ext cx="3209925" cy="3032760"/>
+          </a:xfrm>
+          <a:prstGeom prst="rect">
+            <a:avLst/>
+          </a:prstGeom>
+          <a:noFill/>
+        </p:spPr>
+      </p:pic>
+      <p:pic>
+        <p:nvPicPr>
+          <p:cNvPr id="35" name="Изображение 34" descr="Рисунок1"/>
+          <p:cNvPicPr>
+            <a:picLocks noChangeAspect="1"/>
+          </p:cNvPicPr>
+          <p:nvPr/>
+        </p:nvPicPr>
+        <p:blipFill>
+          <a:blip r:embed="rId3"/>
+          <a:stretch>
+            <a:fillRect/>
+          </a:stretch>
+        </p:blipFill>
+        <p:spPr>
+          <a:xfrm>
+            <a:off x="3507740" y="14570710"/>
+            <a:ext cx="8119745" cy="5120640"/>
+          </a:xfrm>
+          <a:prstGeom prst="rect">
+            <a:avLst/>
+          </a:prstGeom>
+        </p:spPr>
+      </p:pic>
+      <p:pic>
+        <p:nvPicPr>
+          <p:cNvPr id="27" name="Изображение 26" descr="MyLogo"/>
+          <p:cNvPicPr>
+            <a:picLocks noChangeAspect="1"/>
+          </p:cNvPicPr>
+          <p:nvPr/>
+        </p:nvPicPr>
+        <p:blipFill>
+          <a:blip r:embed="rId4"/>
+          <a:stretch>
+            <a:fillRect/>
+          </a:stretch>
+        </p:blipFill>
+        <p:spPr>
+          <a:xfrm>
+            <a:off x="4180205" y="-7166610"/>
+            <a:ext cx="3832225" cy="3832225"/>
+          </a:xfrm>
+          <a:prstGeom prst="rect">
+            <a:avLst/>
+          </a:prstGeom>
+        </p:spPr>
+      </p:pic>
     </p:spTree>
   </p:cSld>
   <p:clrMapOvr>
@@ -4506,7 +5448,7 @@
       </p:grpSpPr>
       <p:pic>
         <p:nvPicPr>
-          <p:cNvPr id="4" name="Picture 3" descr="Logo"/>
+          <p:cNvPr id="35" name="Изображение 34" descr="Рисунок1"/>
           <p:cNvPicPr>
             <a:picLocks noChangeAspect="1"/>
           </p:cNvPicPr>
@@ -4520,59 +5462,14 @@
         </p:blipFill>
         <p:spPr>
           <a:xfrm>
-            <a:off x="3694430" y="511175"/>
-            <a:ext cx="4802505" cy="3250565"/>
+            <a:off x="3411855" y="511175"/>
+            <a:ext cx="8119745" cy="4955540"/>
           </a:xfrm>
           <a:prstGeom prst="rect">
             <a:avLst/>
           </a:prstGeom>
         </p:spPr>
       </p:pic>
-      <p:sp>
-        <p:nvSpPr>
-          <p:cNvPr id="3" name="Овал 2"/>
-          <p:cNvSpPr/>
-          <p:nvPr/>
-        </p:nvSpPr>
-        <p:spPr>
-          <a:xfrm>
-            <a:off x="9364345" y="3761740"/>
-            <a:ext cx="3628390" cy="3628390"/>
-          </a:xfrm>
-          <a:prstGeom prst="ellipse">
-            <a:avLst/>
-          </a:prstGeom>
-          <a:solidFill>
-            <a:srgbClr val="0016A0"/>
-          </a:solidFill>
-          <a:ln>
-            <a:noFill/>
-          </a:ln>
-        </p:spPr>
-        <p:style>
-          <a:lnRef idx="2">
-            <a:schemeClr val="accent1">
-              <a:lumMod val="75000"/>
-            </a:schemeClr>
-          </a:lnRef>
-          <a:fillRef idx="1">
-            <a:schemeClr val="accent1"/>
-          </a:fillRef>
-          <a:effectRef idx="0">
-            <a:srgbClr val="FFFFFF"/>
-          </a:effectRef>
-          <a:fontRef idx="minor">
-            <a:schemeClr val="lt1"/>
-          </a:fontRef>
-        </p:style>
-        <p:txBody>
-          <a:bodyPr rtlCol="0" anchor="ctr"/>
-          <a:p>
-            <a:pPr algn="ctr"/>
-            <a:endParaRPr lang="ru-RU" altLang="en-US"/>
-          </a:p>
-        </p:txBody>
-      </p:sp>
       <p:sp>
         <p:nvSpPr>
           <p:cNvPr id="5" name="Скругленный прямоугольник 4"/>
@@ -4581,8 +5478,8 @@
         </p:nvSpPr>
         <p:spPr>
           <a:xfrm>
-            <a:off x="-528955" y="511175"/>
-            <a:ext cx="3129915" cy="4954905"/>
+            <a:off x="-624840" y="511175"/>
+            <a:ext cx="3754755" cy="4954905"/>
           </a:xfrm>
           <a:prstGeom prst="roundRect">
             <a:avLst/>
@@ -4630,6 +5527,3075 @@
           </a:p>
         </p:txBody>
       </p:sp>
+      <p:sp>
+        <p:nvSpPr>
+          <p:cNvPr id="2" name="Текстовое поле 1"/>
+          <p:cNvSpPr txBox="1"/>
+          <p:nvPr/>
+        </p:nvSpPr>
+        <p:spPr>
+          <a:xfrm>
+            <a:off x="149225" y="1280160"/>
+            <a:ext cx="2844165" cy="368300"/>
+          </a:xfrm>
+          <a:prstGeom prst="rect">
+            <a:avLst/>
+          </a:prstGeom>
+          <a:noFill/>
+        </p:spPr>
+        <p:txBody>
+          <a:bodyPr wrap="square" rtlCol="0">
+            <a:spAutoFit/>
+          </a:bodyPr>
+          <a:p>
+            <a:pPr algn="r"/>
+            <a:r>
+              <a:rPr lang="ru-RU" altLang="en-US">
+                <a:solidFill>
+                  <a:schemeClr val="bg1"/>
+                </a:solidFill>
+                <a:latin typeface="Franklin Gothic Medium" panose="020B0603020102020204" charset="0"/>
+                <a:cs typeface="Franklin Gothic Medium" panose="020B0603020102020204" charset="0"/>
+              </a:rPr>
+              <a:t>Жанр и аудитория</a:t>
+            </a:r>
+            <a:endParaRPr lang="ru-RU" altLang="en-US">
+              <a:solidFill>
+                <a:schemeClr val="bg1"/>
+              </a:solidFill>
+              <a:latin typeface="Franklin Gothic Medium" panose="020B0603020102020204" charset="0"/>
+              <a:cs typeface="Franklin Gothic Medium" panose="020B0603020102020204" charset="0"/>
+            </a:endParaRPr>
+          </a:p>
+        </p:txBody>
+      </p:sp>
+      <p:sp>
+        <p:nvSpPr>
+          <p:cNvPr id="9" name="Текстовое поле 8"/>
+          <p:cNvSpPr txBox="1"/>
+          <p:nvPr/>
+        </p:nvSpPr>
+        <p:spPr>
+          <a:xfrm>
+            <a:off x="0" y="2837180"/>
+            <a:ext cx="2993390" cy="460375"/>
+          </a:xfrm>
+          <a:prstGeom prst="rect">
+            <a:avLst/>
+          </a:prstGeom>
+          <a:noFill/>
+        </p:spPr>
+        <p:txBody>
+          <a:bodyPr wrap="square" rtlCol="0">
+            <a:spAutoFit/>
+          </a:bodyPr>
+          <a:p>
+            <a:pPr algn="r"/>
+            <a:r>
+              <a:rPr lang="ru-RU" altLang="en-US" sz="2400">
+                <a:solidFill>
+                  <a:schemeClr val="bg1"/>
+                </a:solidFill>
+                <a:latin typeface="Franklin Gothic Medium" panose="020B0603020102020204" charset="0"/>
+                <a:cs typeface="Franklin Gothic Medium" panose="020B0603020102020204" charset="0"/>
+              </a:rPr>
+              <a:t>Основные механики</a:t>
+            </a:r>
+            <a:endParaRPr lang="ru-RU" altLang="en-US" sz="2400">
+              <a:solidFill>
+                <a:schemeClr val="bg1"/>
+              </a:solidFill>
+              <a:latin typeface="Franklin Gothic Medium" panose="020B0603020102020204" charset="0"/>
+              <a:cs typeface="Franklin Gothic Medium" panose="020B0603020102020204" charset="0"/>
+            </a:endParaRPr>
+          </a:p>
+        </p:txBody>
+      </p:sp>
+      <p:pic>
+        <p:nvPicPr>
+          <p:cNvPr id="10" name="Изображение 9" descr="image 5-1"/>
+          <p:cNvPicPr>
+            <a:picLocks noChangeAspect="1"/>
+          </p:cNvPicPr>
+          <p:nvPr/>
+        </p:nvPicPr>
+        <p:blipFill>
+          <a:blip r:embed="rId2"/>
+          <a:stretch>
+            <a:fillRect/>
+          </a:stretch>
+        </p:blipFill>
+        <p:spPr>
+          <a:xfrm>
+            <a:off x="23851870" y="-1478280"/>
+            <a:ext cx="2787650" cy="2758440"/>
+          </a:xfrm>
+          <a:prstGeom prst="rect">
+            <a:avLst/>
+          </a:prstGeom>
+        </p:spPr>
+      </p:pic>
+      <p:sp>
+        <p:nvSpPr>
+          <p:cNvPr id="16" name="Скругленный прямоугольник 15"/>
+          <p:cNvSpPr/>
+          <p:nvPr/>
+        </p:nvSpPr>
+        <p:spPr>
+          <a:xfrm>
+            <a:off x="3609975" y="-10526395"/>
+            <a:ext cx="5565775" cy="1257300"/>
+          </a:xfrm>
+          <a:prstGeom prst="roundRect">
+            <a:avLst/>
+          </a:prstGeom>
+          <a:solidFill>
+            <a:srgbClr val="4040B2"/>
+          </a:solidFill>
+          <a:ln w="63500">
+            <a:gradFill>
+              <a:gsLst>
+                <a:gs pos="0">
+                  <a:srgbClr val="00A0FC"/>
+                </a:gs>
+                <a:gs pos="100000">
+                  <a:srgbClr val="1B00EA"/>
+                </a:gs>
+              </a:gsLst>
+              <a:path path="rect">
+                <a:fillToRect l="50000" t="50000" r="50000" b="50000"/>
+              </a:path>
+              <a:tileRect/>
+            </a:gradFill>
+          </a:ln>
+        </p:spPr>
+        <p:style>
+          <a:lnRef idx="2">
+            <a:schemeClr val="accent1">
+              <a:lumMod val="75000"/>
+            </a:schemeClr>
+          </a:lnRef>
+          <a:fillRef idx="1">
+            <a:schemeClr val="accent1"/>
+          </a:fillRef>
+          <a:effectRef idx="0">
+            <a:srgbClr val="FFFFFF"/>
+          </a:effectRef>
+          <a:fontRef idx="minor">
+            <a:schemeClr val="lt1"/>
+          </a:fontRef>
+        </p:style>
+        <p:txBody>
+          <a:bodyPr rtlCol="0" anchor="ctr"/>
+          <a:p>
+            <a:pPr algn="ctr"/>
+            <a:endParaRPr lang="ru-RU" altLang="en-US"/>
+          </a:p>
+        </p:txBody>
+      </p:sp>
+      <p:sp>
+        <p:nvSpPr>
+          <p:cNvPr id="18" name="Текстовое поле 17"/>
+          <p:cNvSpPr txBox="1"/>
+          <p:nvPr/>
+        </p:nvSpPr>
+        <p:spPr>
+          <a:xfrm>
+            <a:off x="3783330" y="-10445115"/>
+            <a:ext cx="5201920" cy="1042670"/>
+          </a:xfrm>
+          <a:prstGeom prst="rect">
+            <a:avLst/>
+          </a:prstGeom>
+          <a:noFill/>
+        </p:spPr>
+        <p:txBody>
+          <a:bodyPr wrap="square" rtlCol="0" anchor="ctr" anchorCtr="0">
+            <a:noAutofit/>
+          </a:bodyPr>
+          <a:p>
+            <a:pPr algn="l">
+              <a:lnSpc>
+                <a:spcPct val="100000"/>
+              </a:lnSpc>
+            </a:pPr>
+            <a:r>
+              <a:rPr lang="en-US" altLang="en-US" sz="2400">
+                <a:solidFill>
+                  <a:srgbClr val="9FE5FF"/>
+                </a:solidFill>
+                <a:latin typeface="Bahnschrift" panose="020B0502040204020203" charset="0"/>
+                <a:cs typeface="Bahnschrift" panose="020B0502040204020203" charset="0"/>
+                <a:sym typeface="+mn-ea"/>
+              </a:rPr>
+              <a:t>Жанр</a:t>
+            </a:r>
+            <a:r>
+              <a:rPr lang="en-US" altLang="ru-RU" sz="2400">
+                <a:solidFill>
+                  <a:srgbClr val="9FE5FF"/>
+                </a:solidFill>
+                <a:latin typeface="Bahnschrift" panose="020B0502040204020203" charset="0"/>
+                <a:cs typeface="Bahnschrift" panose="020B0502040204020203" charset="0"/>
+                <a:sym typeface="+mn-ea"/>
+              </a:rPr>
+              <a:t> </a:t>
+            </a:r>
+            <a:r>
+              <a:rPr lang="en-US" altLang="en-US" sz="2400">
+                <a:solidFill>
+                  <a:srgbClr val="9FE5FF"/>
+                </a:solidFill>
+                <a:latin typeface="Bahnschrift" panose="020B0502040204020203" charset="0"/>
+                <a:cs typeface="Bahnschrift" panose="020B0502040204020203" charset="0"/>
+                <a:sym typeface="+mn-ea"/>
+              </a:rPr>
+              <a:t>игры</a:t>
+            </a:r>
+            <a:endParaRPr lang="en-US" altLang="ru-RU" sz="2400">
+              <a:solidFill>
+                <a:srgbClr val="9FE5FF"/>
+              </a:solidFill>
+              <a:latin typeface="Bahnschrift" panose="020B0502040204020203" charset="0"/>
+              <a:cs typeface="Bahnschrift" panose="020B0502040204020203" charset="0"/>
+            </a:endParaRPr>
+          </a:p>
+          <a:p>
+            <a:pPr algn="ctr">
+              <a:lnSpc>
+                <a:spcPct val="100000"/>
+              </a:lnSpc>
+            </a:pPr>
+            <a:r>
+              <a:rPr lang="en-US" altLang="ru-RU" sz="2800">
+                <a:solidFill>
+                  <a:schemeClr val="bg1"/>
+                </a:solidFill>
+                <a:latin typeface="Franklin Gothic Medium" panose="020B0603020102020204" charset="0"/>
+                <a:cs typeface="Franklin Gothic Medium" panose="020B0603020102020204" charset="0"/>
+              </a:rPr>
+              <a:t>3D </a:t>
+            </a:r>
+            <a:r>
+              <a:rPr lang="en-US" altLang="en-US" sz="2800">
+                <a:solidFill>
+                  <a:schemeClr val="bg1"/>
+                </a:solidFill>
+                <a:latin typeface="Franklin Gothic Medium" panose="020B0603020102020204" charset="0"/>
+                <a:cs typeface="Franklin Gothic Medium" panose="020B0603020102020204" charset="0"/>
+              </a:rPr>
+              <a:t>головоломка</a:t>
+            </a:r>
+            <a:endParaRPr lang="ru-RU" altLang="en-US" sz="2800">
+              <a:solidFill>
+                <a:schemeClr val="bg1"/>
+              </a:solidFill>
+              <a:latin typeface="Franklin Gothic Medium" panose="020B0603020102020204" charset="0"/>
+              <a:cs typeface="Franklin Gothic Medium" panose="020B0603020102020204" charset="0"/>
+            </a:endParaRPr>
+          </a:p>
+        </p:txBody>
+      </p:sp>
+      <p:sp>
+        <p:nvSpPr>
+          <p:cNvPr id="21" name="Скругленный прямоугольник 20"/>
+          <p:cNvSpPr/>
+          <p:nvPr/>
+        </p:nvSpPr>
+        <p:spPr>
+          <a:xfrm>
+            <a:off x="4040505" y="-1853565"/>
+            <a:ext cx="5565775" cy="1257300"/>
+          </a:xfrm>
+          <a:prstGeom prst="roundRect">
+            <a:avLst/>
+          </a:prstGeom>
+          <a:solidFill>
+            <a:srgbClr val="4040B2"/>
+          </a:solidFill>
+          <a:ln w="63500">
+            <a:gradFill>
+              <a:gsLst>
+                <a:gs pos="0">
+                  <a:srgbClr val="00A0FC"/>
+                </a:gs>
+                <a:gs pos="100000">
+                  <a:srgbClr val="1B00EA"/>
+                </a:gs>
+              </a:gsLst>
+              <a:path path="rect">
+                <a:fillToRect l="50000" t="50000" r="50000" b="50000"/>
+              </a:path>
+              <a:tileRect/>
+            </a:gradFill>
+          </a:ln>
+        </p:spPr>
+        <p:style>
+          <a:lnRef idx="2">
+            <a:schemeClr val="accent1">
+              <a:lumMod val="75000"/>
+            </a:schemeClr>
+          </a:lnRef>
+          <a:fillRef idx="1">
+            <a:schemeClr val="accent1"/>
+          </a:fillRef>
+          <a:effectRef idx="0">
+            <a:srgbClr val="FFFFFF"/>
+          </a:effectRef>
+          <a:fontRef idx="minor">
+            <a:schemeClr val="lt1"/>
+          </a:fontRef>
+        </p:style>
+        <p:txBody>
+          <a:bodyPr rtlCol="0" anchor="ctr"/>
+          <a:p>
+            <a:pPr algn="ctr"/>
+            <a:endParaRPr lang="ru-RU" altLang="en-US"/>
+          </a:p>
+        </p:txBody>
+      </p:sp>
+      <p:sp>
+        <p:nvSpPr>
+          <p:cNvPr id="22" name="Текстовое поле 21"/>
+          <p:cNvSpPr txBox="1"/>
+          <p:nvPr/>
+        </p:nvSpPr>
+        <p:spPr>
+          <a:xfrm>
+            <a:off x="4213860" y="-1772285"/>
+            <a:ext cx="5201920" cy="1042670"/>
+          </a:xfrm>
+          <a:prstGeom prst="rect">
+            <a:avLst/>
+          </a:prstGeom>
+          <a:noFill/>
+        </p:spPr>
+        <p:txBody>
+          <a:bodyPr wrap="square" rtlCol="0" anchor="ctr" anchorCtr="0">
+            <a:noAutofit/>
+          </a:bodyPr>
+          <a:p>
+            <a:pPr algn="l">
+              <a:lnSpc>
+                <a:spcPct val="100000"/>
+              </a:lnSpc>
+            </a:pPr>
+            <a:r>
+              <a:rPr lang="ru-RU" altLang="en-US" sz="2400">
+                <a:solidFill>
+                  <a:srgbClr val="9FE5FF"/>
+                </a:solidFill>
+                <a:latin typeface="Bahnschrift" panose="020B0502040204020203" charset="0"/>
+                <a:cs typeface="Bahnschrift" panose="020B0502040204020203" charset="0"/>
+                <a:sym typeface="+mn-ea"/>
+              </a:rPr>
+              <a:t>Аудитория</a:t>
+            </a:r>
+            <a:endParaRPr lang="en-US" altLang="ru-RU" sz="2400">
+              <a:solidFill>
+                <a:srgbClr val="9FE5FF"/>
+              </a:solidFill>
+              <a:latin typeface="Bahnschrift" panose="020B0502040204020203" charset="0"/>
+              <a:cs typeface="Bahnschrift" panose="020B0502040204020203" charset="0"/>
+            </a:endParaRPr>
+          </a:p>
+          <a:p>
+            <a:pPr algn="ctr">
+              <a:lnSpc>
+                <a:spcPct val="100000"/>
+              </a:lnSpc>
+            </a:pPr>
+            <a:r>
+              <a:rPr lang="ru-RU" altLang="en-US" sz="2800">
+                <a:solidFill>
+                  <a:schemeClr val="bg1"/>
+                </a:solidFill>
+                <a:latin typeface="Franklin Gothic Medium" panose="020B0603020102020204" charset="0"/>
+                <a:cs typeface="Franklin Gothic Medium" panose="020B0603020102020204" charset="0"/>
+              </a:rPr>
+              <a:t>Л</a:t>
+            </a:r>
+            <a:r>
+              <a:rPr lang="en-US" altLang="en-US" sz="2800">
+                <a:solidFill>
+                  <a:schemeClr val="bg1"/>
+                </a:solidFill>
+                <a:latin typeface="Franklin Gothic Medium" panose="020B0603020102020204" charset="0"/>
+                <a:cs typeface="Franklin Gothic Medium" panose="020B0603020102020204" charset="0"/>
+              </a:rPr>
+              <a:t>юбители</a:t>
+            </a:r>
+            <a:r>
+              <a:rPr lang="en-US" altLang="ru-RU" sz="2800">
+                <a:solidFill>
+                  <a:schemeClr val="bg1"/>
+                </a:solidFill>
+                <a:latin typeface="Franklin Gothic Medium" panose="020B0603020102020204" charset="0"/>
+                <a:cs typeface="Franklin Gothic Medium" panose="020B0603020102020204" charset="0"/>
+              </a:rPr>
+              <a:t> </a:t>
+            </a:r>
+            <a:r>
+              <a:rPr lang="en-US" altLang="en-US" sz="2800">
+                <a:solidFill>
+                  <a:schemeClr val="bg1"/>
+                </a:solidFill>
+                <a:latin typeface="Franklin Gothic Medium" panose="020B0603020102020204" charset="0"/>
+                <a:cs typeface="Franklin Gothic Medium" panose="020B0603020102020204" charset="0"/>
+              </a:rPr>
+              <a:t>логических</a:t>
+            </a:r>
+            <a:r>
+              <a:rPr lang="en-US" altLang="ru-RU" sz="2800">
+                <a:solidFill>
+                  <a:schemeClr val="bg1"/>
+                </a:solidFill>
+                <a:latin typeface="Franklin Gothic Medium" panose="020B0603020102020204" charset="0"/>
+                <a:cs typeface="Franklin Gothic Medium" panose="020B0603020102020204" charset="0"/>
+              </a:rPr>
+              <a:t> </a:t>
+            </a:r>
+            <a:r>
+              <a:rPr lang="en-US" altLang="en-US" sz="2800">
+                <a:solidFill>
+                  <a:schemeClr val="bg1"/>
+                </a:solidFill>
+                <a:latin typeface="Franklin Gothic Medium" panose="020B0603020102020204" charset="0"/>
+                <a:cs typeface="Franklin Gothic Medium" panose="020B0603020102020204" charset="0"/>
+              </a:rPr>
+              <a:t>игр</a:t>
+            </a:r>
+            <a:r>
+              <a:rPr lang="en-US" altLang="ru-RU" sz="2800">
+                <a:solidFill>
+                  <a:schemeClr val="bg1"/>
+                </a:solidFill>
+                <a:latin typeface="Franklin Gothic Medium" panose="020B0603020102020204" charset="0"/>
+                <a:cs typeface="Franklin Gothic Medium" panose="020B0603020102020204" charset="0"/>
+              </a:rPr>
+              <a:t>.</a:t>
+            </a:r>
+            <a:endParaRPr lang="ru-RU" altLang="en-US" sz="2800">
+              <a:solidFill>
+                <a:schemeClr val="bg1"/>
+              </a:solidFill>
+              <a:latin typeface="Franklin Gothic Medium" panose="020B0603020102020204" charset="0"/>
+              <a:cs typeface="Franklin Gothic Medium" panose="020B0603020102020204" charset="0"/>
+            </a:endParaRPr>
+          </a:p>
+        </p:txBody>
+      </p:sp>
+      <p:sp>
+        <p:nvSpPr>
+          <p:cNvPr id="17" name="Овал 16"/>
+          <p:cNvSpPr/>
+          <p:nvPr/>
+        </p:nvSpPr>
+        <p:spPr>
+          <a:xfrm rot="180000">
+            <a:off x="20021550" y="688340"/>
+            <a:ext cx="794385" cy="794385"/>
+          </a:xfrm>
+          <a:prstGeom prst="ellipse">
+            <a:avLst/>
+          </a:prstGeom>
+          <a:solidFill>
+            <a:srgbClr val="318DFF"/>
+          </a:solidFill>
+          <a:ln>
+            <a:noFill/>
+          </a:ln>
+        </p:spPr>
+        <p:style>
+          <a:lnRef idx="2">
+            <a:schemeClr val="accent1">
+              <a:lumMod val="75000"/>
+            </a:schemeClr>
+          </a:lnRef>
+          <a:fillRef idx="1">
+            <a:schemeClr val="accent1"/>
+          </a:fillRef>
+          <a:effectRef idx="0">
+            <a:srgbClr val="FFFFFF"/>
+          </a:effectRef>
+          <a:fontRef idx="minor">
+            <a:schemeClr val="lt1"/>
+          </a:fontRef>
+        </p:style>
+        <p:txBody>
+          <a:bodyPr rtlCol="0" anchor="ctr"/>
+          <a:p>
+            <a:pPr algn="ctr"/>
+            <a:endParaRPr lang="ru-RU" altLang="en-US"/>
+          </a:p>
+        </p:txBody>
+      </p:sp>
+      <p:sp>
+        <p:nvSpPr>
+          <p:cNvPr id="19" name="Текстовое поле 18"/>
+          <p:cNvSpPr txBox="1"/>
+          <p:nvPr/>
+        </p:nvSpPr>
+        <p:spPr>
+          <a:xfrm rot="180000">
+            <a:off x="20020915" y="687705"/>
+            <a:ext cx="794385" cy="795655"/>
+          </a:xfrm>
+          <a:prstGeom prst="rect">
+            <a:avLst/>
+          </a:prstGeom>
+          <a:noFill/>
+        </p:spPr>
+        <p:txBody>
+          <a:bodyPr wrap="square" rtlCol="0" anchor="ctr" anchorCtr="0">
+            <a:noAutofit/>
+          </a:bodyPr>
+          <a:p>
+            <a:pPr algn="ctr"/>
+            <a:r>
+              <a:rPr lang="ru-RU" altLang="en-US" sz="2800">
+                <a:solidFill>
+                  <a:schemeClr val="bg1"/>
+                </a:solidFill>
+                <a:latin typeface="Bahnschrift" panose="020B0502040204020203" charset="0"/>
+                <a:cs typeface="Bahnschrift" panose="020B0502040204020203" charset="0"/>
+              </a:rPr>
+              <a:t>8+</a:t>
+            </a:r>
+            <a:endParaRPr lang="ru-RU" altLang="en-US" sz="2800">
+              <a:solidFill>
+                <a:schemeClr val="bg1"/>
+              </a:solidFill>
+              <a:latin typeface="Bahnschrift" panose="020B0502040204020203" charset="0"/>
+              <a:cs typeface="Bahnschrift" panose="020B0502040204020203" charset="0"/>
+            </a:endParaRPr>
+          </a:p>
+        </p:txBody>
+      </p:sp>
+      <p:sp>
+        <p:nvSpPr>
+          <p:cNvPr id="23" name="Овал 22"/>
+          <p:cNvSpPr/>
+          <p:nvPr/>
+        </p:nvSpPr>
+        <p:spPr>
+          <a:xfrm rot="180000">
+            <a:off x="3420745" y="-2216150"/>
+            <a:ext cx="353695" cy="353695"/>
+          </a:xfrm>
+          <a:prstGeom prst="ellipse">
+            <a:avLst/>
+          </a:prstGeom>
+          <a:solidFill>
+            <a:srgbClr val="3F31FF"/>
+          </a:solidFill>
+          <a:ln>
+            <a:noFill/>
+          </a:ln>
+        </p:spPr>
+        <p:style>
+          <a:lnRef idx="2">
+            <a:schemeClr val="accent1">
+              <a:lumMod val="75000"/>
+            </a:schemeClr>
+          </a:lnRef>
+          <a:fillRef idx="1">
+            <a:schemeClr val="accent1"/>
+          </a:fillRef>
+          <a:effectRef idx="0">
+            <a:srgbClr val="FFFFFF"/>
+          </a:effectRef>
+          <a:fontRef idx="minor">
+            <a:schemeClr val="lt1"/>
+          </a:fontRef>
+        </p:style>
+        <p:txBody>
+          <a:bodyPr rtlCol="0" anchor="ctr"/>
+          <a:p>
+            <a:pPr algn="ctr"/>
+            <a:endParaRPr lang="ru-RU" altLang="en-US"/>
+          </a:p>
+        </p:txBody>
+      </p:sp>
+      <p:sp>
+        <p:nvSpPr>
+          <p:cNvPr id="25" name="Овал 24"/>
+          <p:cNvSpPr/>
+          <p:nvPr/>
+        </p:nvSpPr>
+        <p:spPr>
+          <a:xfrm rot="180000">
+            <a:off x="8521065" y="-6906895"/>
+            <a:ext cx="353695" cy="353695"/>
+          </a:xfrm>
+          <a:prstGeom prst="ellipse">
+            <a:avLst/>
+          </a:prstGeom>
+          <a:solidFill>
+            <a:srgbClr val="3F31FF"/>
+          </a:solidFill>
+          <a:ln>
+            <a:noFill/>
+          </a:ln>
+        </p:spPr>
+        <p:style>
+          <a:lnRef idx="2">
+            <a:schemeClr val="accent1">
+              <a:lumMod val="75000"/>
+            </a:schemeClr>
+          </a:lnRef>
+          <a:fillRef idx="1">
+            <a:schemeClr val="accent1"/>
+          </a:fillRef>
+          <a:effectRef idx="0">
+            <a:srgbClr val="FFFFFF"/>
+          </a:effectRef>
+          <a:fontRef idx="minor">
+            <a:schemeClr val="lt1"/>
+          </a:fontRef>
+        </p:style>
+        <p:txBody>
+          <a:bodyPr rtlCol="0" anchor="ctr"/>
+          <a:p>
+            <a:pPr algn="ctr"/>
+            <a:endParaRPr lang="ru-RU" altLang="en-US"/>
+          </a:p>
+        </p:txBody>
+      </p:sp>
+      <p:sp>
+        <p:nvSpPr>
+          <p:cNvPr id="20" name="Текстовое поле 19"/>
+          <p:cNvSpPr txBox="1"/>
+          <p:nvPr/>
+        </p:nvSpPr>
+        <p:spPr>
+          <a:xfrm>
+            <a:off x="0" y="4248150"/>
+            <a:ext cx="2993390" cy="368300"/>
+          </a:xfrm>
+          <a:prstGeom prst="rect">
+            <a:avLst/>
+          </a:prstGeom>
+          <a:noFill/>
+        </p:spPr>
+        <p:txBody>
+          <a:bodyPr wrap="square" rtlCol="0">
+            <a:spAutoFit/>
+          </a:bodyPr>
+          <a:p>
+            <a:pPr algn="r"/>
+            <a:r>
+              <a:rPr lang="ru-RU" altLang="en-US">
+                <a:solidFill>
+                  <a:schemeClr val="bg1"/>
+                </a:solidFill>
+                <a:latin typeface="Franklin Gothic Medium" panose="020B0603020102020204" charset="0"/>
+                <a:cs typeface="Franklin Gothic Medium" panose="020B0603020102020204" charset="0"/>
+              </a:rPr>
+              <a:t>Водная комната</a:t>
+            </a:r>
+            <a:endParaRPr lang="ru-RU" altLang="en-US">
+              <a:solidFill>
+                <a:schemeClr val="bg1"/>
+              </a:solidFill>
+              <a:latin typeface="Franklin Gothic Medium" panose="020B0603020102020204" charset="0"/>
+              <a:cs typeface="Franklin Gothic Medium" panose="020B0603020102020204" charset="0"/>
+            </a:endParaRPr>
+          </a:p>
+        </p:txBody>
+      </p:sp>
+      <p:pic>
+        <p:nvPicPr>
+          <p:cNvPr id="32" name="Изображение 31" descr="image 5"/>
+          <p:cNvPicPr>
+            <a:picLocks noChangeAspect="1"/>
+          </p:cNvPicPr>
+          <p:nvPr/>
+        </p:nvPicPr>
+        <p:blipFill>
+          <a:blip r:embed="rId3"/>
+          <a:stretch>
+            <a:fillRect/>
+          </a:stretch>
+        </p:blipFill>
+        <p:spPr>
+          <a:xfrm>
+            <a:off x="7865110" y="1095375"/>
+            <a:ext cx="3209925" cy="3032760"/>
+          </a:xfrm>
+          <a:prstGeom prst="rect">
+            <a:avLst/>
+          </a:prstGeom>
+          <a:noFill/>
+        </p:spPr>
+      </p:pic>
+      <p:sp>
+        <p:nvSpPr>
+          <p:cNvPr id="36" name="Овал 35"/>
+          <p:cNvSpPr/>
+          <p:nvPr/>
+        </p:nvSpPr>
+        <p:spPr>
+          <a:xfrm>
+            <a:off x="10712450" y="6707505"/>
+            <a:ext cx="7025640" cy="7025640"/>
+          </a:xfrm>
+          <a:prstGeom prst="ellipse">
+            <a:avLst/>
+          </a:prstGeom>
+          <a:solidFill>
+            <a:srgbClr val="0033B6"/>
+          </a:solidFill>
+          <a:ln>
+            <a:noFill/>
+          </a:ln>
+        </p:spPr>
+        <p:style>
+          <a:lnRef idx="2">
+            <a:schemeClr val="accent1">
+              <a:lumMod val="75000"/>
+            </a:schemeClr>
+          </a:lnRef>
+          <a:fillRef idx="1">
+            <a:schemeClr val="accent1"/>
+          </a:fillRef>
+          <a:effectRef idx="0">
+            <a:srgbClr val="FFFFFF"/>
+          </a:effectRef>
+          <a:fontRef idx="minor">
+            <a:schemeClr val="lt1"/>
+          </a:fontRef>
+        </p:style>
+        <p:txBody>
+          <a:bodyPr rtlCol="0" anchor="ctr"/>
+          <a:p>
+            <a:pPr algn="ctr"/>
+            <a:endParaRPr lang="ru-RU" altLang="en-US"/>
+          </a:p>
+        </p:txBody>
+      </p:sp>
+      <p:sp>
+        <p:nvSpPr>
+          <p:cNvPr id="37" name="Овал 36"/>
+          <p:cNvSpPr/>
+          <p:nvPr/>
+        </p:nvSpPr>
+        <p:spPr>
+          <a:xfrm>
+            <a:off x="28207970" y="5668645"/>
+            <a:ext cx="2925445" cy="2925445"/>
+          </a:xfrm>
+          <a:prstGeom prst="ellipse">
+            <a:avLst/>
+          </a:prstGeom>
+          <a:solidFill>
+            <a:srgbClr val="315DFF"/>
+          </a:solidFill>
+          <a:ln>
+            <a:noFill/>
+          </a:ln>
+        </p:spPr>
+        <p:style>
+          <a:lnRef idx="2">
+            <a:schemeClr val="accent1">
+              <a:lumMod val="75000"/>
+            </a:schemeClr>
+          </a:lnRef>
+          <a:fillRef idx="1">
+            <a:schemeClr val="accent1"/>
+          </a:fillRef>
+          <a:effectRef idx="0">
+            <a:srgbClr val="FFFFFF"/>
+          </a:effectRef>
+          <a:fontRef idx="minor">
+            <a:schemeClr val="lt1"/>
+          </a:fontRef>
+        </p:style>
+        <p:txBody>
+          <a:bodyPr rtlCol="0" anchor="ctr"/>
+          <a:p>
+            <a:pPr algn="ctr"/>
+            <a:endParaRPr lang="ru-RU" altLang="en-US"/>
+          </a:p>
+        </p:txBody>
+      </p:sp>
+      <p:sp>
+        <p:nvSpPr>
+          <p:cNvPr id="38" name="Текстовое поле 37"/>
+          <p:cNvSpPr txBox="1"/>
+          <p:nvPr/>
+        </p:nvSpPr>
+        <p:spPr>
+          <a:xfrm>
+            <a:off x="-4132580" y="4248150"/>
+            <a:ext cx="2844165" cy="368300"/>
+          </a:xfrm>
+          <a:prstGeom prst="rect">
+            <a:avLst/>
+          </a:prstGeom>
+          <a:noFill/>
+        </p:spPr>
+        <p:txBody>
+          <a:bodyPr wrap="square" rtlCol="0" anchor="ctr" anchorCtr="0">
+            <a:spAutoFit/>
+          </a:bodyPr>
+          <a:p>
+            <a:pPr algn="ctr"/>
+            <a:r>
+              <a:rPr lang="ru-RU" altLang="en-US">
+                <a:solidFill>
+                  <a:schemeClr val="bg1"/>
+                </a:solidFill>
+                <a:latin typeface="Franklin Gothic Medium" panose="020B0603020102020204" charset="0"/>
+                <a:cs typeface="Franklin Gothic Medium" panose="020B0603020102020204" charset="0"/>
+              </a:rPr>
+              <a:t>Прыгун</a:t>
+            </a:r>
+            <a:endParaRPr lang="ru-RU" altLang="en-US">
+              <a:solidFill>
+                <a:schemeClr val="bg1"/>
+              </a:solidFill>
+              <a:latin typeface="Franklin Gothic Medium" panose="020B0603020102020204" charset="0"/>
+              <a:cs typeface="Franklin Gothic Medium" panose="020B0603020102020204" charset="0"/>
+            </a:endParaRPr>
+          </a:p>
+        </p:txBody>
+      </p:sp>
+      <p:pic>
+        <p:nvPicPr>
+          <p:cNvPr id="39" name="Изображение 38"/>
+          <p:cNvPicPr>
+            <a:picLocks noChangeAspect="1"/>
+          </p:cNvPicPr>
+          <p:nvPr/>
+        </p:nvPicPr>
+        <p:blipFill>
+          <a:blip r:embed="rId4"/>
+          <a:stretch>
+            <a:fillRect/>
+          </a:stretch>
+        </p:blipFill>
+        <p:spPr>
+          <a:xfrm>
+            <a:off x="1227455" y="8594090"/>
+            <a:ext cx="8188325" cy="4116070"/>
+          </a:xfrm>
+          <a:prstGeom prst="rect">
+            <a:avLst/>
+          </a:prstGeom>
+          <a:ln w="63500">
+            <a:gradFill>
+              <a:gsLst>
+                <a:gs pos="0">
+                  <a:srgbClr val="00A0FC"/>
+                </a:gs>
+                <a:gs pos="100000">
+                  <a:srgbClr val="1B00EA"/>
+                </a:gs>
+              </a:gsLst>
+              <a:lin ang="4620000" scaled="0"/>
+            </a:gradFill>
+          </a:ln>
+        </p:spPr>
+      </p:pic>
+    </p:spTree>
+  </p:cSld>
+  <p:clrMapOvr>
+    <a:masterClrMapping/>
+  </p:clrMapOvr>
+  <mc:AlternateContent xmlns:mc="http://schemas.openxmlformats.org/markup-compatibility/2006" xmlns:p159="http://schemas.microsoft.com/office/powerpoint/2015/09/main">
+    <mc:Choice Requires="p159">
+      <p:transition xmlns:p14="http://schemas.microsoft.com/office/powerpoint/2010/main" spd="slow" p14:dur="1500">
+        <p159:morph option="byObject"/>
+      </p:transition>
+    </mc:Choice>
+    <mc:Fallback>
+      <p:transition spd="slow">
+        <p:fade/>
+      </p:transition>
+    </mc:Fallback>
+  </mc:AlternateContent>
+</p:sld>
+</file>
+
+<file path=ppt/slides/slide4.xml><?xml version="1.0" encoding="utf-8"?>
+<p:sld xmlns:a="http://schemas.openxmlformats.org/drawingml/2006/main" xmlns:r="http://schemas.openxmlformats.org/officeDocument/2006/relationships" xmlns:p="http://schemas.openxmlformats.org/presentationml/2006/main">
+  <p:cSld>
+    <p:bg>
+      <p:bgPr>
+        <a:solidFill>
+          <a:srgbClr val="E1EEFF"/>
+        </a:solidFill>
+        <a:effectLst/>
+      </p:bgPr>
+    </p:bg>
+    <p:spTree>
+      <p:nvGrpSpPr>
+        <p:cNvPr id="1" name=""/>
+        <p:cNvGrpSpPr/>
+        <p:nvPr/>
+      </p:nvGrpSpPr>
+      <p:grpSpPr>
+        <a:xfrm>
+          <a:off x="0" y="0"/>
+          <a:ext cx="0" cy="0"/>
+          <a:chOff x="0" y="0"/>
+          <a:chExt cx="0" cy="0"/>
+        </a:xfrm>
+      </p:grpSpPr>
+      <p:sp>
+        <p:nvSpPr>
+          <p:cNvPr id="11" name="Овал 10"/>
+          <p:cNvSpPr/>
+          <p:nvPr/>
+        </p:nvSpPr>
+        <p:spPr>
+          <a:xfrm>
+            <a:off x="6782435" y="1761490"/>
+            <a:ext cx="7025640" cy="7025640"/>
+          </a:xfrm>
+          <a:prstGeom prst="ellipse">
+            <a:avLst/>
+          </a:prstGeom>
+          <a:solidFill>
+            <a:srgbClr val="0033B6"/>
+          </a:solidFill>
+          <a:ln>
+            <a:noFill/>
+          </a:ln>
+        </p:spPr>
+        <p:style>
+          <a:lnRef idx="2">
+            <a:schemeClr val="accent1">
+              <a:lumMod val="75000"/>
+            </a:schemeClr>
+          </a:lnRef>
+          <a:fillRef idx="1">
+            <a:schemeClr val="accent1"/>
+          </a:fillRef>
+          <a:effectRef idx="0">
+            <a:srgbClr val="FFFFFF"/>
+          </a:effectRef>
+          <a:fontRef idx="minor">
+            <a:schemeClr val="lt1"/>
+          </a:fontRef>
+        </p:style>
+        <p:txBody>
+          <a:bodyPr rtlCol="0" anchor="ctr"/>
+          <a:p>
+            <a:pPr algn="ctr"/>
+            <a:endParaRPr lang="ru-RU" altLang="en-US"/>
+          </a:p>
+        </p:txBody>
+      </p:sp>
+      <p:pic>
+        <p:nvPicPr>
+          <p:cNvPr id="35" name="Изображение 34" descr="Рисунок1"/>
+          <p:cNvPicPr>
+            <a:picLocks noChangeAspect="1"/>
+          </p:cNvPicPr>
+          <p:nvPr/>
+        </p:nvPicPr>
+        <p:blipFill>
+          <a:blip r:embed="rId1"/>
+          <a:stretch>
+            <a:fillRect/>
+          </a:stretch>
+        </p:blipFill>
+        <p:spPr>
+          <a:xfrm>
+            <a:off x="3783330" y="-6455410"/>
+            <a:ext cx="8119745" cy="4955540"/>
+          </a:xfrm>
+          <a:prstGeom prst="rect">
+            <a:avLst/>
+          </a:prstGeom>
+        </p:spPr>
+      </p:pic>
+      <p:sp>
+        <p:nvSpPr>
+          <p:cNvPr id="5" name="Скругленный прямоугольник 4"/>
+          <p:cNvSpPr/>
+          <p:nvPr/>
+        </p:nvSpPr>
+        <p:spPr>
+          <a:xfrm>
+            <a:off x="-624840" y="511175"/>
+            <a:ext cx="3754755" cy="4954905"/>
+          </a:xfrm>
+          <a:prstGeom prst="roundRect">
+            <a:avLst/>
+          </a:prstGeom>
+          <a:solidFill>
+            <a:srgbClr val="4040B2">
+              <a:alpha val="67000"/>
+            </a:srgbClr>
+          </a:solidFill>
+          <a:ln w="63500">
+            <a:gradFill>
+              <a:gsLst>
+                <a:gs pos="0">
+                  <a:srgbClr val="00A0FC"/>
+                </a:gs>
+                <a:gs pos="100000">
+                  <a:srgbClr val="1B00EA"/>
+                </a:gs>
+              </a:gsLst>
+              <a:lin ang="4740000" scaled="1"/>
+            </a:gradFill>
+          </a:ln>
+        </p:spPr>
+        <p:style>
+          <a:lnRef idx="2">
+            <a:schemeClr val="accent1">
+              <a:lumMod val="75000"/>
+            </a:schemeClr>
+          </a:lnRef>
+          <a:fillRef idx="1">
+            <a:schemeClr val="accent1"/>
+          </a:fillRef>
+          <a:effectRef idx="0">
+            <a:srgbClr val="FFFFFF"/>
+          </a:effectRef>
+          <a:fontRef idx="minor">
+            <a:schemeClr val="lt1"/>
+          </a:fontRef>
+        </p:style>
+        <p:txBody>
+          <a:bodyPr rtlCol="0" anchor="ctr"/>
+          <a:p>
+            <a:pPr algn="ctr"/>
+            <a:endParaRPr lang="ru-RU" altLang="en-US"/>
+          </a:p>
+        </p:txBody>
+      </p:sp>
+      <p:sp>
+        <p:nvSpPr>
+          <p:cNvPr id="2" name="Текстовое поле 1"/>
+          <p:cNvSpPr txBox="1"/>
+          <p:nvPr/>
+        </p:nvSpPr>
+        <p:spPr>
+          <a:xfrm>
+            <a:off x="-4786630" y="1280160"/>
+            <a:ext cx="2844165" cy="368300"/>
+          </a:xfrm>
+          <a:prstGeom prst="rect">
+            <a:avLst/>
+          </a:prstGeom>
+          <a:noFill/>
+        </p:spPr>
+        <p:txBody>
+          <a:bodyPr wrap="square" rtlCol="0">
+            <a:spAutoFit/>
+          </a:bodyPr>
+          <a:p>
+            <a:pPr algn="ctr"/>
+            <a:r>
+              <a:rPr lang="ru-RU" altLang="en-US">
+                <a:solidFill>
+                  <a:schemeClr val="bg1"/>
+                </a:solidFill>
+                <a:latin typeface="Franklin Gothic Medium" panose="020B0603020102020204" charset="0"/>
+                <a:cs typeface="Franklin Gothic Medium" panose="020B0603020102020204" charset="0"/>
+              </a:rPr>
+              <a:t>Жанр и аудитория</a:t>
+            </a:r>
+            <a:endParaRPr lang="ru-RU" altLang="en-US">
+              <a:solidFill>
+                <a:schemeClr val="bg1"/>
+              </a:solidFill>
+              <a:latin typeface="Franklin Gothic Medium" panose="020B0603020102020204" charset="0"/>
+              <a:cs typeface="Franklin Gothic Medium" panose="020B0603020102020204" charset="0"/>
+            </a:endParaRPr>
+          </a:p>
+        </p:txBody>
+      </p:sp>
+      <p:sp>
+        <p:nvSpPr>
+          <p:cNvPr id="8" name="Овал 7"/>
+          <p:cNvSpPr/>
+          <p:nvPr/>
+        </p:nvSpPr>
+        <p:spPr>
+          <a:xfrm>
+            <a:off x="10257155" y="4385945"/>
+            <a:ext cx="2925445" cy="2925445"/>
+          </a:xfrm>
+          <a:prstGeom prst="ellipse">
+            <a:avLst/>
+          </a:prstGeom>
+          <a:solidFill>
+            <a:srgbClr val="315DFF"/>
+          </a:solidFill>
+          <a:ln>
+            <a:noFill/>
+          </a:ln>
+        </p:spPr>
+        <p:style>
+          <a:lnRef idx="2">
+            <a:schemeClr val="accent1">
+              <a:lumMod val="75000"/>
+            </a:schemeClr>
+          </a:lnRef>
+          <a:fillRef idx="1">
+            <a:schemeClr val="accent1"/>
+          </a:fillRef>
+          <a:effectRef idx="0">
+            <a:srgbClr val="FFFFFF"/>
+          </a:effectRef>
+          <a:fontRef idx="minor">
+            <a:schemeClr val="lt1"/>
+          </a:fontRef>
+        </p:style>
+        <p:txBody>
+          <a:bodyPr rtlCol="0" anchor="ctr"/>
+          <a:p>
+            <a:pPr algn="ctr"/>
+            <a:endParaRPr lang="ru-RU" altLang="en-US"/>
+          </a:p>
+        </p:txBody>
+      </p:sp>
+      <p:sp>
+        <p:nvSpPr>
+          <p:cNvPr id="9" name="Текстовое поле 8"/>
+          <p:cNvSpPr txBox="1"/>
+          <p:nvPr/>
+        </p:nvSpPr>
+        <p:spPr>
+          <a:xfrm>
+            <a:off x="-39370" y="1188085"/>
+            <a:ext cx="2993390" cy="368300"/>
+          </a:xfrm>
+          <a:prstGeom prst="rect">
+            <a:avLst/>
+          </a:prstGeom>
+          <a:noFill/>
+        </p:spPr>
+        <p:txBody>
+          <a:bodyPr wrap="square" rtlCol="0">
+            <a:spAutoFit/>
+          </a:bodyPr>
+          <a:p>
+            <a:pPr algn="r"/>
+            <a:r>
+              <a:rPr lang="ru-RU" altLang="en-US">
+                <a:solidFill>
+                  <a:schemeClr val="bg1"/>
+                </a:solidFill>
+                <a:latin typeface="Franklin Gothic Medium" panose="020B0603020102020204" charset="0"/>
+                <a:cs typeface="Franklin Gothic Medium" panose="020B0603020102020204" charset="0"/>
+              </a:rPr>
+              <a:t>Основные механики</a:t>
+            </a:r>
+            <a:endParaRPr lang="ru-RU" altLang="en-US">
+              <a:solidFill>
+                <a:schemeClr val="bg1"/>
+              </a:solidFill>
+              <a:latin typeface="Franklin Gothic Medium" panose="020B0603020102020204" charset="0"/>
+              <a:cs typeface="Franklin Gothic Medium" panose="020B0603020102020204" charset="0"/>
+            </a:endParaRPr>
+          </a:p>
+        </p:txBody>
+      </p:sp>
+      <p:sp>
+        <p:nvSpPr>
+          <p:cNvPr id="20" name="Текстовое поле 19"/>
+          <p:cNvSpPr txBox="1"/>
+          <p:nvPr/>
+        </p:nvSpPr>
+        <p:spPr>
+          <a:xfrm>
+            <a:off x="0" y="2785110"/>
+            <a:ext cx="2993390" cy="460375"/>
+          </a:xfrm>
+          <a:prstGeom prst="rect">
+            <a:avLst/>
+          </a:prstGeom>
+          <a:noFill/>
+        </p:spPr>
+        <p:txBody>
+          <a:bodyPr wrap="square" rtlCol="0" anchor="ctr" anchorCtr="0">
+            <a:spAutoFit/>
+          </a:bodyPr>
+          <a:p>
+            <a:pPr algn="r"/>
+            <a:r>
+              <a:rPr lang="ru-RU" altLang="en-US" sz="2400">
+                <a:solidFill>
+                  <a:schemeClr val="bg1"/>
+                </a:solidFill>
+                <a:latin typeface="Franklin Gothic Medium" panose="020B0603020102020204" charset="0"/>
+                <a:cs typeface="Franklin Gothic Medium" panose="020B0603020102020204" charset="0"/>
+              </a:rPr>
+              <a:t>Водная комната</a:t>
+            </a:r>
+            <a:endParaRPr lang="ru-RU" altLang="en-US" sz="2400">
+              <a:solidFill>
+                <a:schemeClr val="bg1"/>
+              </a:solidFill>
+              <a:latin typeface="Franklin Gothic Medium" panose="020B0603020102020204" charset="0"/>
+              <a:cs typeface="Franklin Gothic Medium" panose="020B0603020102020204" charset="0"/>
+            </a:endParaRPr>
+          </a:p>
+        </p:txBody>
+      </p:sp>
+      <p:pic>
+        <p:nvPicPr>
+          <p:cNvPr id="32" name="Изображение 31" descr="image 5"/>
+          <p:cNvPicPr>
+            <a:picLocks noChangeAspect="1"/>
+          </p:cNvPicPr>
+          <p:nvPr/>
+        </p:nvPicPr>
+        <p:blipFill>
+          <a:blip r:embed="rId2"/>
+          <a:stretch>
+            <a:fillRect/>
+          </a:stretch>
+        </p:blipFill>
+        <p:spPr>
+          <a:xfrm>
+            <a:off x="15734665" y="-6206490"/>
+            <a:ext cx="3209925" cy="3032760"/>
+          </a:xfrm>
+          <a:prstGeom prst="rect">
+            <a:avLst/>
+          </a:prstGeom>
+          <a:noFill/>
+        </p:spPr>
+      </p:pic>
+      <p:sp>
+        <p:nvSpPr>
+          <p:cNvPr id="3" name="Текстовое поле 2"/>
+          <p:cNvSpPr txBox="1"/>
+          <p:nvPr/>
+        </p:nvSpPr>
+        <p:spPr>
+          <a:xfrm>
+            <a:off x="109855" y="4474210"/>
+            <a:ext cx="2844165" cy="368300"/>
+          </a:xfrm>
+          <a:prstGeom prst="rect">
+            <a:avLst/>
+          </a:prstGeom>
+          <a:noFill/>
+        </p:spPr>
+        <p:txBody>
+          <a:bodyPr wrap="square" rtlCol="0" anchor="ctr" anchorCtr="0">
+            <a:spAutoFit/>
+          </a:bodyPr>
+          <a:p>
+            <a:pPr algn="r"/>
+            <a:r>
+              <a:rPr lang="ru-RU" altLang="en-US">
+                <a:solidFill>
+                  <a:schemeClr val="bg1"/>
+                </a:solidFill>
+                <a:latin typeface="Franklin Gothic Medium" panose="020B0603020102020204" charset="0"/>
+                <a:cs typeface="Franklin Gothic Medium" panose="020B0603020102020204" charset="0"/>
+              </a:rPr>
+              <a:t>Прыгун</a:t>
+            </a:r>
+            <a:endParaRPr lang="ru-RU" altLang="en-US">
+              <a:solidFill>
+                <a:schemeClr val="bg1"/>
+              </a:solidFill>
+              <a:latin typeface="Franklin Gothic Medium" panose="020B0603020102020204" charset="0"/>
+              <a:cs typeface="Franklin Gothic Medium" panose="020B0603020102020204" charset="0"/>
+            </a:endParaRPr>
+          </a:p>
+        </p:txBody>
+      </p:sp>
+      <p:pic>
+        <p:nvPicPr>
+          <p:cNvPr id="7" name="Изображение 6"/>
+          <p:cNvPicPr>
+            <a:picLocks noChangeAspect="1"/>
+          </p:cNvPicPr>
+          <p:nvPr/>
+        </p:nvPicPr>
+        <p:blipFill>
+          <a:blip r:embed="rId3"/>
+          <a:stretch>
+            <a:fillRect/>
+          </a:stretch>
+        </p:blipFill>
+        <p:spPr>
+          <a:xfrm>
+            <a:off x="3486785" y="957580"/>
+            <a:ext cx="8188325" cy="4116070"/>
+          </a:xfrm>
+          <a:prstGeom prst="rect">
+            <a:avLst/>
+          </a:prstGeom>
+          <a:ln w="63500">
+            <a:gradFill>
+              <a:gsLst>
+                <a:gs pos="0">
+                  <a:srgbClr val="00A0FC"/>
+                </a:gs>
+                <a:gs pos="100000">
+                  <a:srgbClr val="1B00EA"/>
+                </a:gs>
+              </a:gsLst>
+              <a:lin ang="4620000" scaled="0"/>
+            </a:gradFill>
+          </a:ln>
+        </p:spPr>
+      </p:pic>
+      <p:sp>
+        <p:nvSpPr>
+          <p:cNvPr id="12" name="Текстовое поле 11"/>
+          <p:cNvSpPr txBox="1"/>
+          <p:nvPr/>
+        </p:nvSpPr>
+        <p:spPr>
+          <a:xfrm>
+            <a:off x="-3975100" y="4374515"/>
+            <a:ext cx="2993390" cy="645160"/>
+          </a:xfrm>
+          <a:prstGeom prst="rect">
+            <a:avLst/>
+          </a:prstGeom>
+          <a:noFill/>
+        </p:spPr>
+        <p:txBody>
+          <a:bodyPr wrap="square" rtlCol="0">
+            <a:spAutoFit/>
+          </a:bodyPr>
+          <a:p>
+            <a:pPr algn="r"/>
+            <a:r>
+              <a:rPr lang="ru-RU" altLang="en-US">
+                <a:solidFill>
+                  <a:schemeClr val="bg1"/>
+                </a:solidFill>
+                <a:latin typeface="Franklin Gothic Medium" panose="020B0603020102020204" charset="0"/>
+                <a:cs typeface="Franklin Gothic Medium" panose="020B0603020102020204" charset="0"/>
+              </a:rPr>
+              <a:t>Описание проиизводительности</a:t>
+            </a:r>
+            <a:endParaRPr lang="ru-RU" altLang="en-US">
+              <a:solidFill>
+                <a:schemeClr val="bg1"/>
+              </a:solidFill>
+              <a:latin typeface="Franklin Gothic Medium" panose="020B0603020102020204" charset="0"/>
+              <a:cs typeface="Franklin Gothic Medium" panose="020B0603020102020204" charset="0"/>
+            </a:endParaRPr>
+          </a:p>
+        </p:txBody>
+      </p:sp>
+    </p:spTree>
+  </p:cSld>
+  <p:clrMapOvr>
+    <a:masterClrMapping/>
+  </p:clrMapOvr>
+  <mc:AlternateContent xmlns:mc="http://schemas.openxmlformats.org/markup-compatibility/2006" xmlns:p159="http://schemas.microsoft.com/office/powerpoint/2015/09/main">
+    <mc:Choice Requires="p159">
+      <p:transition xmlns:p14="http://schemas.microsoft.com/office/powerpoint/2010/main" spd="slow" p14:dur="1500">
+        <p159:morph option="byObject"/>
+      </p:transition>
+    </mc:Choice>
+    <mc:Fallback>
+      <p:transition spd="slow">
+        <p:fade/>
+      </p:transition>
+    </mc:Fallback>
+  </mc:AlternateContent>
+</p:sld>
+</file>
+
+<file path=ppt/slides/slide5.xml><?xml version="1.0" encoding="utf-8"?>
+<p:sld xmlns:a="http://schemas.openxmlformats.org/drawingml/2006/main" xmlns:r="http://schemas.openxmlformats.org/officeDocument/2006/relationships" xmlns:p="http://schemas.openxmlformats.org/presentationml/2006/main">
+  <p:cSld>
+    <p:bg>
+      <p:bgPr>
+        <a:solidFill>
+          <a:srgbClr val="E1EEFF"/>
+        </a:solidFill>
+        <a:effectLst/>
+      </p:bgPr>
+    </p:bg>
+    <p:spTree>
+      <p:nvGrpSpPr>
+        <p:cNvPr id="1" name=""/>
+        <p:cNvGrpSpPr/>
+        <p:nvPr/>
+      </p:nvGrpSpPr>
+      <p:grpSpPr>
+        <a:xfrm>
+          <a:off x="0" y="0"/>
+          <a:ext cx="0" cy="0"/>
+          <a:chOff x="0" y="0"/>
+          <a:chExt cx="0" cy="0"/>
+        </a:xfrm>
+      </p:grpSpPr>
+      <p:sp>
+        <p:nvSpPr>
+          <p:cNvPr id="11" name="Овал 10"/>
+          <p:cNvSpPr/>
+          <p:nvPr/>
+        </p:nvSpPr>
+        <p:spPr>
+          <a:xfrm>
+            <a:off x="7832725" y="-1145540"/>
+            <a:ext cx="7025640" cy="7025640"/>
+          </a:xfrm>
+          <a:prstGeom prst="ellipse">
+            <a:avLst/>
+          </a:prstGeom>
+          <a:solidFill>
+            <a:srgbClr val="0033B6"/>
+          </a:solidFill>
+          <a:ln>
+            <a:noFill/>
+          </a:ln>
+        </p:spPr>
+        <p:style>
+          <a:lnRef idx="2">
+            <a:schemeClr val="accent1">
+              <a:lumMod val="75000"/>
+            </a:schemeClr>
+          </a:lnRef>
+          <a:fillRef idx="1">
+            <a:schemeClr val="accent1"/>
+          </a:fillRef>
+          <a:effectRef idx="0">
+            <a:srgbClr val="FFFFFF"/>
+          </a:effectRef>
+          <a:fontRef idx="minor">
+            <a:schemeClr val="lt1"/>
+          </a:fontRef>
+        </p:style>
+        <p:txBody>
+          <a:bodyPr rtlCol="0" anchor="ctr"/>
+          <a:p>
+            <a:pPr algn="ctr"/>
+            <a:endParaRPr lang="ru-RU" altLang="en-US"/>
+          </a:p>
+        </p:txBody>
+      </p:sp>
+      <p:sp>
+        <p:nvSpPr>
+          <p:cNvPr id="5" name="Скругленный прямоугольник 4"/>
+          <p:cNvSpPr/>
+          <p:nvPr/>
+        </p:nvSpPr>
+        <p:spPr>
+          <a:xfrm>
+            <a:off x="-624840" y="511175"/>
+            <a:ext cx="3754755" cy="4954905"/>
+          </a:xfrm>
+          <a:prstGeom prst="roundRect">
+            <a:avLst/>
+          </a:prstGeom>
+          <a:solidFill>
+            <a:srgbClr val="4040B2">
+              <a:alpha val="67000"/>
+            </a:srgbClr>
+          </a:solidFill>
+          <a:ln w="63500">
+            <a:gradFill>
+              <a:gsLst>
+                <a:gs pos="0">
+                  <a:srgbClr val="00A0FC"/>
+                </a:gs>
+                <a:gs pos="100000">
+                  <a:srgbClr val="1B00EA"/>
+                </a:gs>
+              </a:gsLst>
+              <a:lin ang="4740000" scaled="1"/>
+            </a:gradFill>
+          </a:ln>
+        </p:spPr>
+        <p:style>
+          <a:lnRef idx="2">
+            <a:schemeClr val="accent1">
+              <a:lumMod val="75000"/>
+            </a:schemeClr>
+          </a:lnRef>
+          <a:fillRef idx="1">
+            <a:schemeClr val="accent1"/>
+          </a:fillRef>
+          <a:effectRef idx="0">
+            <a:srgbClr val="FFFFFF"/>
+          </a:effectRef>
+          <a:fontRef idx="minor">
+            <a:schemeClr val="lt1"/>
+          </a:fontRef>
+        </p:style>
+        <p:txBody>
+          <a:bodyPr rtlCol="0" anchor="ctr"/>
+          <a:p>
+            <a:pPr algn="ctr"/>
+            <a:endParaRPr lang="ru-RU" altLang="en-US"/>
+          </a:p>
+        </p:txBody>
+      </p:sp>
+      <p:sp>
+        <p:nvSpPr>
+          <p:cNvPr id="8" name="Овал 7"/>
+          <p:cNvSpPr/>
+          <p:nvPr/>
+        </p:nvSpPr>
+        <p:spPr>
+          <a:xfrm>
+            <a:off x="10454005" y="-765810"/>
+            <a:ext cx="2925445" cy="2925445"/>
+          </a:xfrm>
+          <a:prstGeom prst="ellipse">
+            <a:avLst/>
+          </a:prstGeom>
+          <a:solidFill>
+            <a:srgbClr val="315DFF"/>
+          </a:solidFill>
+          <a:ln>
+            <a:noFill/>
+          </a:ln>
+        </p:spPr>
+        <p:style>
+          <a:lnRef idx="2">
+            <a:schemeClr val="accent1">
+              <a:lumMod val="75000"/>
+            </a:schemeClr>
+          </a:lnRef>
+          <a:fillRef idx="1">
+            <a:schemeClr val="accent1"/>
+          </a:fillRef>
+          <a:effectRef idx="0">
+            <a:srgbClr val="FFFFFF"/>
+          </a:effectRef>
+          <a:fontRef idx="minor">
+            <a:schemeClr val="lt1"/>
+          </a:fontRef>
+        </p:style>
+        <p:txBody>
+          <a:bodyPr rtlCol="0" anchor="ctr"/>
+          <a:p>
+            <a:pPr algn="ctr"/>
+            <a:endParaRPr lang="ru-RU" altLang="en-US"/>
+          </a:p>
+        </p:txBody>
+      </p:sp>
+      <p:sp>
+        <p:nvSpPr>
+          <p:cNvPr id="9" name="Текстовое поле 8"/>
+          <p:cNvSpPr txBox="1"/>
+          <p:nvPr/>
+        </p:nvSpPr>
+        <p:spPr>
+          <a:xfrm>
+            <a:off x="-5541010" y="1188085"/>
+            <a:ext cx="2993390" cy="368300"/>
+          </a:xfrm>
+          <a:prstGeom prst="rect">
+            <a:avLst/>
+          </a:prstGeom>
+          <a:noFill/>
+        </p:spPr>
+        <p:txBody>
+          <a:bodyPr wrap="square" rtlCol="0">
+            <a:spAutoFit/>
+          </a:bodyPr>
+          <a:p>
+            <a:pPr algn="ctr"/>
+            <a:r>
+              <a:rPr lang="ru-RU" altLang="en-US">
+                <a:solidFill>
+                  <a:schemeClr val="bg1"/>
+                </a:solidFill>
+                <a:latin typeface="Franklin Gothic Medium" panose="020B0603020102020204" charset="0"/>
+                <a:cs typeface="Franklin Gothic Medium" panose="020B0603020102020204" charset="0"/>
+              </a:rPr>
+              <a:t>Основные механики</a:t>
+            </a:r>
+            <a:endParaRPr lang="ru-RU" altLang="en-US">
+              <a:solidFill>
+                <a:schemeClr val="bg1"/>
+              </a:solidFill>
+              <a:latin typeface="Franklin Gothic Medium" panose="020B0603020102020204" charset="0"/>
+              <a:cs typeface="Franklin Gothic Medium" panose="020B0603020102020204" charset="0"/>
+            </a:endParaRPr>
+          </a:p>
+        </p:txBody>
+      </p:sp>
+      <p:sp>
+        <p:nvSpPr>
+          <p:cNvPr id="20" name="Текстовое поле 19"/>
+          <p:cNvSpPr txBox="1"/>
+          <p:nvPr/>
+        </p:nvSpPr>
+        <p:spPr>
+          <a:xfrm>
+            <a:off x="-12700" y="1234123"/>
+            <a:ext cx="2993390" cy="368300"/>
+          </a:xfrm>
+          <a:prstGeom prst="rect">
+            <a:avLst/>
+          </a:prstGeom>
+          <a:noFill/>
+        </p:spPr>
+        <p:txBody>
+          <a:bodyPr wrap="square" rtlCol="0" anchor="ctr" anchorCtr="0">
+            <a:spAutoFit/>
+          </a:bodyPr>
+          <a:p>
+            <a:pPr algn="r"/>
+            <a:r>
+              <a:rPr lang="ru-RU" altLang="en-US">
+                <a:solidFill>
+                  <a:schemeClr val="bg1"/>
+                </a:solidFill>
+                <a:latin typeface="Franklin Gothic Medium" panose="020B0603020102020204" charset="0"/>
+                <a:cs typeface="Franklin Gothic Medium" panose="020B0603020102020204" charset="0"/>
+              </a:rPr>
+              <a:t>Водная комната</a:t>
+            </a:r>
+            <a:endParaRPr lang="ru-RU" altLang="en-US">
+              <a:solidFill>
+                <a:schemeClr val="bg1"/>
+              </a:solidFill>
+              <a:latin typeface="Franklin Gothic Medium" panose="020B0603020102020204" charset="0"/>
+              <a:cs typeface="Franklin Gothic Medium" panose="020B0603020102020204" charset="0"/>
+            </a:endParaRPr>
+          </a:p>
+        </p:txBody>
+      </p:sp>
+      <p:sp>
+        <p:nvSpPr>
+          <p:cNvPr id="3" name="Текстовое поле 2"/>
+          <p:cNvSpPr txBox="1"/>
+          <p:nvPr/>
+        </p:nvSpPr>
+        <p:spPr>
+          <a:xfrm>
+            <a:off x="136525" y="2758123"/>
+            <a:ext cx="2844165" cy="460375"/>
+          </a:xfrm>
+          <a:prstGeom prst="rect">
+            <a:avLst/>
+          </a:prstGeom>
+          <a:noFill/>
+        </p:spPr>
+        <p:txBody>
+          <a:bodyPr wrap="square" rtlCol="0" anchor="ctr" anchorCtr="0">
+            <a:spAutoFit/>
+          </a:bodyPr>
+          <a:p>
+            <a:pPr algn="r"/>
+            <a:r>
+              <a:rPr lang="ru-RU" altLang="en-US" sz="2400">
+                <a:solidFill>
+                  <a:schemeClr val="bg1"/>
+                </a:solidFill>
+                <a:latin typeface="Franklin Gothic Medium" panose="020B0603020102020204" charset="0"/>
+                <a:cs typeface="Franklin Gothic Medium" panose="020B0603020102020204" charset="0"/>
+              </a:rPr>
+              <a:t>Прыгун</a:t>
+            </a:r>
+            <a:endParaRPr lang="ru-RU" altLang="en-US" sz="2400">
+              <a:solidFill>
+                <a:schemeClr val="bg1"/>
+              </a:solidFill>
+              <a:latin typeface="Franklin Gothic Medium" panose="020B0603020102020204" charset="0"/>
+              <a:cs typeface="Franklin Gothic Medium" panose="020B0603020102020204" charset="0"/>
+            </a:endParaRPr>
+          </a:p>
+        </p:txBody>
+      </p:sp>
+      <p:pic>
+        <p:nvPicPr>
+          <p:cNvPr id="7" name="Изображение 6"/>
+          <p:cNvPicPr>
+            <a:picLocks noChangeAspect="1"/>
+          </p:cNvPicPr>
+          <p:nvPr/>
+        </p:nvPicPr>
+        <p:blipFill>
+          <a:blip r:embed="rId1"/>
+          <a:stretch>
+            <a:fillRect/>
+          </a:stretch>
+        </p:blipFill>
+        <p:spPr>
+          <a:xfrm>
+            <a:off x="3683635" y="-5261610"/>
+            <a:ext cx="8188325" cy="4116070"/>
+          </a:xfrm>
+          <a:prstGeom prst="rect">
+            <a:avLst/>
+          </a:prstGeom>
+          <a:ln w="63500">
+            <a:gradFill>
+              <a:gsLst>
+                <a:gs pos="0">
+                  <a:srgbClr val="00A0FC"/>
+                </a:gs>
+                <a:gs pos="100000">
+                  <a:srgbClr val="1B00EA"/>
+                </a:gs>
+              </a:gsLst>
+              <a:lin ang="4620000" scaled="0"/>
+            </a:gradFill>
+          </a:ln>
+        </p:spPr>
+      </p:pic>
+      <p:sp>
+        <p:nvSpPr>
+          <p:cNvPr id="4" name="Текстовое поле 3"/>
+          <p:cNvSpPr txBox="1"/>
+          <p:nvPr/>
+        </p:nvSpPr>
+        <p:spPr>
+          <a:xfrm>
+            <a:off x="-12700" y="4374515"/>
+            <a:ext cx="2993390" cy="645160"/>
+          </a:xfrm>
+          <a:prstGeom prst="rect">
+            <a:avLst/>
+          </a:prstGeom>
+          <a:noFill/>
+        </p:spPr>
+        <p:txBody>
+          <a:bodyPr wrap="square" rtlCol="0">
+            <a:spAutoFit/>
+          </a:bodyPr>
+          <a:p>
+            <a:pPr algn="r"/>
+            <a:r>
+              <a:rPr lang="ru-RU" altLang="en-US">
+                <a:solidFill>
+                  <a:schemeClr val="bg1"/>
+                </a:solidFill>
+                <a:latin typeface="Franklin Gothic Medium" panose="020B0603020102020204" charset="0"/>
+                <a:cs typeface="Franklin Gothic Medium" panose="020B0603020102020204" charset="0"/>
+              </a:rPr>
+              <a:t>Описание проиизводительности</a:t>
+            </a:r>
+            <a:endParaRPr lang="ru-RU" altLang="en-US">
+              <a:solidFill>
+                <a:schemeClr val="bg1"/>
+              </a:solidFill>
+              <a:latin typeface="Franklin Gothic Medium" panose="020B0603020102020204" charset="0"/>
+              <a:cs typeface="Franklin Gothic Medium" panose="020B0603020102020204" charset="0"/>
+            </a:endParaRPr>
+          </a:p>
+        </p:txBody>
+      </p:sp>
+      <p:pic>
+        <p:nvPicPr>
+          <p:cNvPr id="19" name="Изображение 18"/>
+          <p:cNvPicPr>
+            <a:picLocks noChangeAspect="1"/>
+          </p:cNvPicPr>
+          <p:nvPr/>
+        </p:nvPicPr>
+        <p:blipFill>
+          <a:blip r:embed="rId2"/>
+          <a:stretch>
+            <a:fillRect/>
+          </a:stretch>
+        </p:blipFill>
+        <p:spPr>
+          <a:xfrm>
+            <a:off x="4620895" y="9740900"/>
+            <a:ext cx="8317230" cy="3142615"/>
+          </a:xfrm>
+          <a:prstGeom prst="rect">
+            <a:avLst/>
+          </a:prstGeom>
+          <a:ln w="63500">
+            <a:gradFill>
+              <a:gsLst>
+                <a:gs pos="0">
+                  <a:srgbClr val="00A0FC"/>
+                </a:gs>
+                <a:gs pos="100000">
+                  <a:srgbClr val="1B00EA"/>
+                </a:gs>
+              </a:gsLst>
+              <a:lin ang="4740000" scaled="1"/>
+            </a:gradFill>
+          </a:ln>
+        </p:spPr>
+      </p:pic>
+    </p:spTree>
+  </p:cSld>
+  <p:clrMapOvr>
+    <a:masterClrMapping/>
+  </p:clrMapOvr>
+  <mc:AlternateContent xmlns:mc="http://schemas.openxmlformats.org/markup-compatibility/2006" xmlns:p159="http://schemas.microsoft.com/office/powerpoint/2015/09/main">
+    <mc:Choice Requires="p159">
+      <p:transition xmlns:p14="http://schemas.microsoft.com/office/powerpoint/2010/main" spd="slow" p14:dur="1500">
+        <p159:morph option="byObject"/>
+      </p:transition>
+    </mc:Choice>
+    <mc:Fallback>
+      <p:transition spd="slow">
+        <p:fade/>
+      </p:transition>
+    </mc:Fallback>
+  </mc:AlternateContent>
+</p:sld>
+</file>
+
+<file path=ppt/slides/slide6.xml><?xml version="1.0" encoding="utf-8"?>
+<p:sld xmlns:a="http://schemas.openxmlformats.org/drawingml/2006/main" xmlns:r="http://schemas.openxmlformats.org/officeDocument/2006/relationships" xmlns:p="http://schemas.openxmlformats.org/presentationml/2006/main">
+  <p:cSld>
+    <p:bg>
+      <p:bgPr>
+        <a:solidFill>
+          <a:srgbClr val="E1EEFF"/>
+        </a:solidFill>
+        <a:effectLst/>
+      </p:bgPr>
+    </p:bg>
+    <p:spTree>
+      <p:nvGrpSpPr>
+        <p:cNvPr id="1" name=""/>
+        <p:cNvGrpSpPr/>
+        <p:nvPr/>
+      </p:nvGrpSpPr>
+      <p:grpSpPr>
+        <a:xfrm>
+          <a:off x="0" y="0"/>
+          <a:ext cx="0" cy="0"/>
+          <a:chOff x="0" y="0"/>
+          <a:chExt cx="0" cy="0"/>
+        </a:xfrm>
+      </p:grpSpPr>
+      <p:sp>
+        <p:nvSpPr>
+          <p:cNvPr id="12" name="Скругленный прямоугольник 11"/>
+          <p:cNvSpPr/>
+          <p:nvPr/>
+        </p:nvSpPr>
+        <p:spPr>
+          <a:xfrm>
+            <a:off x="-624840" y="511175"/>
+            <a:ext cx="3754755" cy="4954905"/>
+          </a:xfrm>
+          <a:prstGeom prst="roundRect">
+            <a:avLst/>
+          </a:prstGeom>
+          <a:solidFill>
+            <a:srgbClr val="4040B2">
+              <a:alpha val="67000"/>
+            </a:srgbClr>
+          </a:solidFill>
+          <a:ln w="63500">
+            <a:gradFill>
+              <a:gsLst>
+                <a:gs pos="0">
+                  <a:srgbClr val="00A0FC"/>
+                </a:gs>
+                <a:gs pos="100000">
+                  <a:srgbClr val="1B00EA"/>
+                </a:gs>
+              </a:gsLst>
+              <a:lin ang="4740000" scaled="1"/>
+            </a:gradFill>
+          </a:ln>
+        </p:spPr>
+        <p:style>
+          <a:lnRef idx="2">
+            <a:schemeClr val="accent1">
+              <a:lumMod val="75000"/>
+            </a:schemeClr>
+          </a:lnRef>
+          <a:fillRef idx="1">
+            <a:schemeClr val="accent1"/>
+          </a:fillRef>
+          <a:effectRef idx="0">
+            <a:srgbClr val="FFFFFF"/>
+          </a:effectRef>
+          <a:fontRef idx="minor">
+            <a:schemeClr val="lt1"/>
+          </a:fontRef>
+        </p:style>
+        <p:txBody>
+          <a:bodyPr rtlCol="0" anchor="ctr"/>
+          <a:p>
+            <a:pPr algn="ctr"/>
+            <a:endParaRPr lang="ru-RU" altLang="en-US"/>
+          </a:p>
+        </p:txBody>
+      </p:sp>
+      <p:sp>
+        <p:nvSpPr>
+          <p:cNvPr id="13" name="Текстовое поле 12"/>
+          <p:cNvSpPr txBox="1"/>
+          <p:nvPr/>
+        </p:nvSpPr>
+        <p:spPr>
+          <a:xfrm>
+            <a:off x="-4005580" y="1234123"/>
+            <a:ext cx="2993390" cy="368300"/>
+          </a:xfrm>
+          <a:prstGeom prst="rect">
+            <a:avLst/>
+          </a:prstGeom>
+          <a:noFill/>
+        </p:spPr>
+        <p:txBody>
+          <a:bodyPr wrap="square" rtlCol="0" anchor="ctr" anchorCtr="0">
+            <a:spAutoFit/>
+          </a:bodyPr>
+          <a:p>
+            <a:pPr algn="r"/>
+            <a:r>
+              <a:rPr lang="ru-RU" altLang="en-US">
+                <a:solidFill>
+                  <a:schemeClr val="bg1"/>
+                </a:solidFill>
+                <a:latin typeface="Franklin Gothic Medium" panose="020B0603020102020204" charset="0"/>
+                <a:cs typeface="Franklin Gothic Medium" panose="020B0603020102020204" charset="0"/>
+              </a:rPr>
+              <a:t>Водная комната</a:t>
+            </a:r>
+            <a:endParaRPr lang="ru-RU" altLang="en-US">
+              <a:solidFill>
+                <a:schemeClr val="bg1"/>
+              </a:solidFill>
+              <a:latin typeface="Franklin Gothic Medium" panose="020B0603020102020204" charset="0"/>
+              <a:cs typeface="Franklin Gothic Medium" panose="020B0603020102020204" charset="0"/>
+            </a:endParaRPr>
+          </a:p>
+        </p:txBody>
+      </p:sp>
+      <p:sp>
+        <p:nvSpPr>
+          <p:cNvPr id="14" name="Текстовое поле 13"/>
+          <p:cNvSpPr txBox="1"/>
+          <p:nvPr/>
+        </p:nvSpPr>
+        <p:spPr>
+          <a:xfrm>
+            <a:off x="136525" y="1280160"/>
+            <a:ext cx="2844165" cy="368300"/>
+          </a:xfrm>
+          <a:prstGeom prst="rect">
+            <a:avLst/>
+          </a:prstGeom>
+          <a:noFill/>
+        </p:spPr>
+        <p:txBody>
+          <a:bodyPr wrap="square" rtlCol="0" anchor="ctr" anchorCtr="0">
+            <a:spAutoFit/>
+          </a:bodyPr>
+          <a:p>
+            <a:pPr algn="r"/>
+            <a:r>
+              <a:rPr lang="ru-RU" altLang="en-US">
+                <a:solidFill>
+                  <a:schemeClr val="bg1"/>
+                </a:solidFill>
+                <a:latin typeface="Franklin Gothic Medium" panose="020B0603020102020204" charset="0"/>
+                <a:cs typeface="Franklin Gothic Medium" panose="020B0603020102020204" charset="0"/>
+              </a:rPr>
+              <a:t>Прыгун</a:t>
+            </a:r>
+            <a:endParaRPr lang="ru-RU" altLang="en-US">
+              <a:solidFill>
+                <a:schemeClr val="bg1"/>
+              </a:solidFill>
+              <a:latin typeface="Franklin Gothic Medium" panose="020B0603020102020204" charset="0"/>
+              <a:cs typeface="Franklin Gothic Medium" panose="020B0603020102020204" charset="0"/>
+            </a:endParaRPr>
+          </a:p>
+        </p:txBody>
+      </p:sp>
+      <p:sp>
+        <p:nvSpPr>
+          <p:cNvPr id="16" name="Текстовое поле 15"/>
+          <p:cNvSpPr txBox="1"/>
+          <p:nvPr/>
+        </p:nvSpPr>
+        <p:spPr>
+          <a:xfrm>
+            <a:off x="-22860" y="2764790"/>
+            <a:ext cx="2993390" cy="798830"/>
+          </a:xfrm>
+          <a:prstGeom prst="rect">
+            <a:avLst/>
+          </a:prstGeom>
+          <a:noFill/>
+        </p:spPr>
+        <p:txBody>
+          <a:bodyPr wrap="square" rtlCol="0">
+            <a:spAutoFit/>
+          </a:bodyPr>
+          <a:p>
+            <a:pPr algn="r"/>
+            <a:r>
+              <a:rPr lang="ru-RU" altLang="en-US" sz="2300">
+                <a:solidFill>
+                  <a:schemeClr val="bg1"/>
+                </a:solidFill>
+                <a:latin typeface="Franklin Gothic Medium" panose="020B0603020102020204" charset="0"/>
+                <a:cs typeface="Franklin Gothic Medium" panose="020B0603020102020204" charset="0"/>
+              </a:rPr>
+              <a:t>Описание проиизводительности</a:t>
+            </a:r>
+            <a:endParaRPr lang="ru-RU" altLang="en-US" sz="2300">
+              <a:solidFill>
+                <a:schemeClr val="bg1"/>
+              </a:solidFill>
+              <a:latin typeface="Franklin Gothic Medium" panose="020B0603020102020204" charset="0"/>
+              <a:cs typeface="Franklin Gothic Medium" panose="020B0603020102020204" charset="0"/>
+            </a:endParaRPr>
+          </a:p>
+        </p:txBody>
+      </p:sp>
+      <p:sp>
+        <p:nvSpPr>
+          <p:cNvPr id="17" name="Овал 16"/>
+          <p:cNvSpPr/>
+          <p:nvPr/>
+        </p:nvSpPr>
+        <p:spPr>
+          <a:xfrm>
+            <a:off x="5455285" y="-3462020"/>
+            <a:ext cx="7025640" cy="7025640"/>
+          </a:xfrm>
+          <a:prstGeom prst="ellipse">
+            <a:avLst/>
+          </a:prstGeom>
+          <a:solidFill>
+            <a:srgbClr val="0033B6"/>
+          </a:solidFill>
+          <a:ln>
+            <a:noFill/>
+          </a:ln>
+        </p:spPr>
+        <p:style>
+          <a:lnRef idx="2">
+            <a:schemeClr val="accent1">
+              <a:lumMod val="75000"/>
+            </a:schemeClr>
+          </a:lnRef>
+          <a:fillRef idx="1">
+            <a:schemeClr val="accent1"/>
+          </a:fillRef>
+          <a:effectRef idx="0">
+            <a:srgbClr val="FFFFFF"/>
+          </a:effectRef>
+          <a:fontRef idx="minor">
+            <a:schemeClr val="lt1"/>
+          </a:fontRef>
+        </p:style>
+        <p:txBody>
+          <a:bodyPr rtlCol="0" anchor="ctr"/>
+          <a:p>
+            <a:pPr algn="ctr"/>
+            <a:endParaRPr lang="ru-RU" altLang="en-US"/>
+          </a:p>
+        </p:txBody>
+      </p:sp>
+      <p:sp>
+        <p:nvSpPr>
+          <p:cNvPr id="18" name="Овал 17"/>
+          <p:cNvSpPr/>
+          <p:nvPr/>
+        </p:nvSpPr>
+        <p:spPr>
+          <a:xfrm>
+            <a:off x="8549005" y="-1786890"/>
+            <a:ext cx="2925445" cy="2925445"/>
+          </a:xfrm>
+          <a:prstGeom prst="ellipse">
+            <a:avLst/>
+          </a:prstGeom>
+          <a:solidFill>
+            <a:srgbClr val="315DFF"/>
+          </a:solidFill>
+          <a:ln>
+            <a:noFill/>
+          </a:ln>
+        </p:spPr>
+        <p:style>
+          <a:lnRef idx="2">
+            <a:schemeClr val="accent1">
+              <a:lumMod val="75000"/>
+            </a:schemeClr>
+          </a:lnRef>
+          <a:fillRef idx="1">
+            <a:schemeClr val="accent1"/>
+          </a:fillRef>
+          <a:effectRef idx="0">
+            <a:srgbClr val="FFFFFF"/>
+          </a:effectRef>
+          <a:fontRef idx="minor">
+            <a:schemeClr val="lt1"/>
+          </a:fontRef>
+        </p:style>
+        <p:txBody>
+          <a:bodyPr rtlCol="0" anchor="ctr"/>
+          <a:p>
+            <a:pPr algn="ctr"/>
+            <a:endParaRPr lang="ru-RU" altLang="en-US"/>
+          </a:p>
+        </p:txBody>
+      </p:sp>
+      <p:pic>
+        <p:nvPicPr>
+          <p:cNvPr id="19" name="Изображение 18"/>
+          <p:cNvPicPr>
+            <a:picLocks noChangeAspect="1"/>
+          </p:cNvPicPr>
+          <p:nvPr/>
+        </p:nvPicPr>
+        <p:blipFill>
+          <a:blip r:embed="rId1"/>
+          <a:stretch>
+            <a:fillRect/>
+          </a:stretch>
+        </p:blipFill>
+        <p:spPr>
+          <a:xfrm>
+            <a:off x="3349625" y="1602740"/>
+            <a:ext cx="8317230" cy="3142615"/>
+          </a:xfrm>
+          <a:prstGeom prst="rect">
+            <a:avLst/>
+          </a:prstGeom>
+          <a:ln w="63500">
+            <a:gradFill>
+              <a:gsLst>
+                <a:gs pos="0">
+                  <a:srgbClr val="00A0FC"/>
+                </a:gs>
+                <a:gs pos="100000">
+                  <a:srgbClr val="1B00EA"/>
+                </a:gs>
+              </a:gsLst>
+              <a:lin ang="4740000" scaled="1"/>
+            </a:gradFill>
+          </a:ln>
+        </p:spPr>
+      </p:pic>
+      <p:sp>
+        <p:nvSpPr>
+          <p:cNvPr id="21" name="Овал 20"/>
+          <p:cNvSpPr/>
+          <p:nvPr/>
+        </p:nvSpPr>
+        <p:spPr>
+          <a:xfrm rot="20940000">
+            <a:off x="12515850" y="9229090"/>
+            <a:ext cx="403225" cy="403225"/>
+          </a:xfrm>
+          <a:prstGeom prst="ellipse">
+            <a:avLst/>
+          </a:prstGeom>
+          <a:solidFill>
+            <a:srgbClr val="0072E6"/>
+          </a:solidFill>
+          <a:ln>
+            <a:noFill/>
+          </a:ln>
+        </p:spPr>
+        <p:style>
+          <a:lnRef idx="2">
+            <a:schemeClr val="accent1">
+              <a:lumMod val="75000"/>
+            </a:schemeClr>
+          </a:lnRef>
+          <a:fillRef idx="1">
+            <a:schemeClr val="accent1"/>
+          </a:fillRef>
+          <a:effectRef idx="0">
+            <a:srgbClr val="FFFFFF"/>
+          </a:effectRef>
+          <a:fontRef idx="minor">
+            <a:schemeClr val="lt1"/>
+          </a:fontRef>
+        </p:style>
+        <p:txBody>
+          <a:bodyPr rtlCol="0" anchor="ctr"/>
+          <a:p>
+            <a:pPr algn="ctr"/>
+            <a:endParaRPr lang="ru-RU" altLang="en-US"/>
+          </a:p>
+        </p:txBody>
+      </p:sp>
+      <p:sp>
+        <p:nvSpPr>
+          <p:cNvPr id="22" name="Скругленный прямоугольник 21"/>
+          <p:cNvSpPr/>
+          <p:nvPr/>
+        </p:nvSpPr>
+        <p:spPr>
+          <a:xfrm>
+            <a:off x="704215" y="8579485"/>
+            <a:ext cx="10962640" cy="3913505"/>
+          </a:xfrm>
+          <a:prstGeom prst="roundRect">
+            <a:avLst/>
+          </a:prstGeom>
+          <a:solidFill>
+            <a:srgbClr val="4040B2"/>
+          </a:solidFill>
+          <a:ln w="63500">
+            <a:gradFill>
+              <a:gsLst>
+                <a:gs pos="0">
+                  <a:srgbClr val="00A0FC"/>
+                </a:gs>
+                <a:gs pos="100000">
+                  <a:srgbClr val="1B00EA"/>
+                </a:gs>
+              </a:gsLst>
+              <a:path path="rect">
+                <a:fillToRect l="50000" t="50000" r="50000" b="50000"/>
+              </a:path>
+              <a:tileRect/>
+            </a:gradFill>
+          </a:ln>
+        </p:spPr>
+        <p:style>
+          <a:lnRef idx="2">
+            <a:schemeClr val="accent1">
+              <a:lumMod val="75000"/>
+            </a:schemeClr>
+          </a:lnRef>
+          <a:fillRef idx="1">
+            <a:schemeClr val="accent1"/>
+          </a:fillRef>
+          <a:effectRef idx="0">
+            <a:srgbClr val="FFFFFF"/>
+          </a:effectRef>
+          <a:fontRef idx="minor">
+            <a:schemeClr val="lt1"/>
+          </a:fontRef>
+        </p:style>
+        <p:txBody>
+          <a:bodyPr rtlCol="0" anchor="ctr"/>
+          <a:p>
+            <a:pPr algn="ctr"/>
+            <a:endParaRPr lang="ru-RU" altLang="en-US"/>
+          </a:p>
+        </p:txBody>
+      </p:sp>
+      <p:sp>
+        <p:nvSpPr>
+          <p:cNvPr id="23" name="Овал 22"/>
+          <p:cNvSpPr/>
+          <p:nvPr/>
+        </p:nvSpPr>
+        <p:spPr>
+          <a:xfrm rot="20940000">
+            <a:off x="12065" y="7842250"/>
+            <a:ext cx="403225" cy="403225"/>
+          </a:xfrm>
+          <a:prstGeom prst="ellipse">
+            <a:avLst/>
+          </a:prstGeom>
+          <a:solidFill>
+            <a:srgbClr val="0072E6"/>
+          </a:solidFill>
+          <a:ln>
+            <a:noFill/>
+          </a:ln>
+        </p:spPr>
+        <p:style>
+          <a:lnRef idx="2">
+            <a:schemeClr val="accent1">
+              <a:lumMod val="75000"/>
+            </a:schemeClr>
+          </a:lnRef>
+          <a:fillRef idx="1">
+            <a:schemeClr val="accent1"/>
+          </a:fillRef>
+          <a:effectRef idx="0">
+            <a:srgbClr val="FFFFFF"/>
+          </a:effectRef>
+          <a:fontRef idx="minor">
+            <a:schemeClr val="lt1"/>
+          </a:fontRef>
+        </p:style>
+        <p:txBody>
+          <a:bodyPr rtlCol="0" anchor="ctr"/>
+          <a:p>
+            <a:pPr algn="ctr"/>
+            <a:endParaRPr lang="ru-RU" altLang="en-US"/>
+          </a:p>
+        </p:txBody>
+      </p:sp>
+      <p:sp>
+        <p:nvSpPr>
+          <p:cNvPr id="24" name="Овал 23"/>
+          <p:cNvSpPr/>
+          <p:nvPr/>
+        </p:nvSpPr>
+        <p:spPr>
+          <a:xfrm rot="20940000">
+            <a:off x="493395" y="13150215"/>
+            <a:ext cx="501650" cy="501650"/>
+          </a:xfrm>
+          <a:prstGeom prst="ellipse">
+            <a:avLst/>
+          </a:prstGeom>
+          <a:solidFill>
+            <a:srgbClr val="0041E6"/>
+          </a:solidFill>
+          <a:ln>
+            <a:noFill/>
+          </a:ln>
+        </p:spPr>
+        <p:style>
+          <a:lnRef idx="2">
+            <a:schemeClr val="accent1">
+              <a:lumMod val="75000"/>
+            </a:schemeClr>
+          </a:lnRef>
+          <a:fillRef idx="1">
+            <a:schemeClr val="accent1"/>
+          </a:fillRef>
+          <a:effectRef idx="0">
+            <a:srgbClr val="FFFFFF"/>
+          </a:effectRef>
+          <a:fontRef idx="minor">
+            <a:schemeClr val="lt1"/>
+          </a:fontRef>
+        </p:style>
+        <p:txBody>
+          <a:bodyPr rtlCol="0" anchor="ctr"/>
+          <a:p>
+            <a:pPr algn="ctr"/>
+            <a:endParaRPr lang="ru-RU" altLang="en-US"/>
+          </a:p>
+        </p:txBody>
+      </p:sp>
+      <p:sp>
+        <p:nvSpPr>
+          <p:cNvPr id="25" name="Овал 24"/>
+          <p:cNvSpPr/>
+          <p:nvPr/>
+        </p:nvSpPr>
+        <p:spPr>
+          <a:xfrm rot="20940000">
+            <a:off x="9585960" y="11506200"/>
+            <a:ext cx="501650" cy="501650"/>
+          </a:xfrm>
+          <a:prstGeom prst="ellipse">
+            <a:avLst/>
+          </a:prstGeom>
+          <a:solidFill>
+            <a:srgbClr val="0041E6"/>
+          </a:solidFill>
+          <a:ln>
+            <a:noFill/>
+          </a:ln>
+        </p:spPr>
+        <p:style>
+          <a:lnRef idx="2">
+            <a:schemeClr val="accent1">
+              <a:lumMod val="75000"/>
+            </a:schemeClr>
+          </a:lnRef>
+          <a:fillRef idx="1">
+            <a:schemeClr val="accent1"/>
+          </a:fillRef>
+          <a:effectRef idx="0">
+            <a:srgbClr val="FFFFFF"/>
+          </a:effectRef>
+          <a:fontRef idx="minor">
+            <a:schemeClr val="lt1"/>
+          </a:fontRef>
+        </p:style>
+        <p:txBody>
+          <a:bodyPr rtlCol="0" anchor="ctr"/>
+          <a:p>
+            <a:pPr algn="ctr"/>
+            <a:endParaRPr lang="ru-RU" altLang="en-US"/>
+          </a:p>
+        </p:txBody>
+      </p:sp>
+      <p:sp>
+        <p:nvSpPr>
+          <p:cNvPr id="26" name="Текстовое поле 25"/>
+          <p:cNvSpPr txBox="1"/>
+          <p:nvPr/>
+        </p:nvSpPr>
+        <p:spPr>
+          <a:xfrm>
+            <a:off x="3349625" y="14073505"/>
+            <a:ext cx="6193155" cy="706755"/>
+          </a:xfrm>
+          <a:prstGeom prst="rect">
+            <a:avLst/>
+          </a:prstGeom>
+          <a:noFill/>
+        </p:spPr>
+        <p:txBody>
+          <a:bodyPr wrap="square" rtlCol="0">
+            <a:spAutoFit/>
+          </a:bodyPr>
+          <a:p>
+            <a:pPr algn="ctr"/>
+            <a:r>
+              <a:rPr lang="ru-RU" altLang="en-US" sz="4000">
+                <a:solidFill>
+                  <a:schemeClr val="bg1"/>
+                </a:solidFill>
+                <a:latin typeface="Franklin Gothic Medium" panose="020B0603020102020204" charset="0"/>
+                <a:cs typeface="Franklin Gothic Medium" panose="020B0603020102020204" charset="0"/>
+              </a:rPr>
+              <a:t>Спасибо за внимание</a:t>
+            </a:r>
+            <a:endParaRPr lang="ru-RU" altLang="en-US" sz="4000">
+              <a:solidFill>
+                <a:schemeClr val="bg1"/>
+              </a:solidFill>
+              <a:latin typeface="Franklin Gothic Medium" panose="020B0603020102020204" charset="0"/>
+              <a:cs typeface="Franklin Gothic Medium" panose="020B0603020102020204" charset="0"/>
+            </a:endParaRPr>
+          </a:p>
+        </p:txBody>
+      </p:sp>
+      <p:pic>
+        <p:nvPicPr>
+          <p:cNvPr id="28" name="Изображение 27" descr="MyLogo"/>
+          <p:cNvPicPr>
+            <a:picLocks noChangeAspect="1"/>
+          </p:cNvPicPr>
+          <p:nvPr/>
+        </p:nvPicPr>
+        <p:blipFill>
+          <a:blip r:embed="rId2"/>
+          <a:stretch>
+            <a:fillRect/>
+          </a:stretch>
+        </p:blipFill>
+        <p:spPr>
+          <a:xfrm>
+            <a:off x="4180205" y="-6063615"/>
+            <a:ext cx="3832225" cy="3832225"/>
+          </a:xfrm>
+          <a:prstGeom prst="rect">
+            <a:avLst/>
+          </a:prstGeom>
+        </p:spPr>
+      </p:pic>
+    </p:spTree>
+  </p:cSld>
+  <p:clrMapOvr>
+    <a:masterClrMapping/>
+  </p:clrMapOvr>
+  <mc:AlternateContent xmlns:mc="http://schemas.openxmlformats.org/markup-compatibility/2006" xmlns:p159="http://schemas.microsoft.com/office/powerpoint/2015/09/main">
+    <mc:Choice Requires="p159">
+      <p:transition xmlns:p14="http://schemas.microsoft.com/office/powerpoint/2010/main" spd="slow" p14:dur="1500">
+        <p159:morph option="byObject"/>
+      </p:transition>
+    </mc:Choice>
+    <mc:Fallback>
+      <p:transition spd="slow">
+        <p:fade/>
+      </p:transition>
+    </mc:Fallback>
+  </mc:AlternateContent>
+</p:sld>
+</file>
+
+<file path=ppt/slides/slide7.xml><?xml version="1.0" encoding="utf-8"?>
+<p:sld xmlns:a="http://schemas.openxmlformats.org/drawingml/2006/main" xmlns:r="http://schemas.openxmlformats.org/officeDocument/2006/relationships" xmlns:p="http://schemas.openxmlformats.org/presentationml/2006/main">
+  <p:cSld>
+    <p:bg>
+      <p:bgPr>
+        <a:solidFill>
+          <a:srgbClr val="E1EEFF"/>
+        </a:solidFill>
+        <a:effectLst/>
+      </p:bgPr>
+    </p:bg>
+    <p:spTree>
+      <p:nvGrpSpPr>
+        <p:cNvPr id="1" name=""/>
+        <p:cNvGrpSpPr/>
+        <p:nvPr/>
+      </p:nvGrpSpPr>
+      <p:grpSpPr>
+        <a:xfrm>
+          <a:off x="0" y="0"/>
+          <a:ext cx="0" cy="0"/>
+          <a:chOff x="0" y="0"/>
+          <a:chExt cx="0" cy="0"/>
+        </a:xfrm>
+      </p:grpSpPr>
+      <p:sp>
+        <p:nvSpPr>
+          <p:cNvPr id="12" name="Скругленный прямоугольник 11"/>
+          <p:cNvSpPr/>
+          <p:nvPr/>
+        </p:nvSpPr>
+        <p:spPr>
+          <a:xfrm>
+            <a:off x="-4599305" y="511175"/>
+            <a:ext cx="3754755" cy="4954905"/>
+          </a:xfrm>
+          <a:prstGeom prst="roundRect">
+            <a:avLst/>
+          </a:prstGeom>
+          <a:solidFill>
+            <a:srgbClr val="4040B2">
+              <a:alpha val="67000"/>
+            </a:srgbClr>
+          </a:solidFill>
+          <a:ln w="63500">
+            <a:gradFill>
+              <a:gsLst>
+                <a:gs pos="0">
+                  <a:srgbClr val="00A0FC"/>
+                </a:gs>
+                <a:gs pos="100000">
+                  <a:srgbClr val="1B00EA"/>
+                </a:gs>
+              </a:gsLst>
+              <a:lin ang="4740000" scaled="1"/>
+            </a:gradFill>
+          </a:ln>
+        </p:spPr>
+        <p:style>
+          <a:lnRef idx="2">
+            <a:schemeClr val="accent1">
+              <a:lumMod val="75000"/>
+            </a:schemeClr>
+          </a:lnRef>
+          <a:fillRef idx="1">
+            <a:schemeClr val="accent1"/>
+          </a:fillRef>
+          <a:effectRef idx="0">
+            <a:srgbClr val="FFFFFF"/>
+          </a:effectRef>
+          <a:fontRef idx="minor">
+            <a:schemeClr val="lt1"/>
+          </a:fontRef>
+        </p:style>
+        <p:txBody>
+          <a:bodyPr rtlCol="0" anchor="ctr"/>
+          <a:p>
+            <a:pPr algn="ctr"/>
+            <a:endParaRPr lang="ru-RU" altLang="en-US"/>
+          </a:p>
+        </p:txBody>
+      </p:sp>
+      <p:sp>
+        <p:nvSpPr>
+          <p:cNvPr id="14" name="Текстовое поле 13"/>
+          <p:cNvSpPr txBox="1"/>
+          <p:nvPr/>
+        </p:nvSpPr>
+        <p:spPr>
+          <a:xfrm>
+            <a:off x="-3837940" y="1280160"/>
+            <a:ext cx="2844165" cy="368300"/>
+          </a:xfrm>
+          <a:prstGeom prst="rect">
+            <a:avLst/>
+          </a:prstGeom>
+          <a:noFill/>
+        </p:spPr>
+        <p:txBody>
+          <a:bodyPr wrap="square" rtlCol="0" anchor="ctr" anchorCtr="0">
+            <a:spAutoFit/>
+          </a:bodyPr>
+          <a:p>
+            <a:pPr algn="r"/>
+            <a:r>
+              <a:rPr lang="ru-RU" altLang="en-US">
+                <a:solidFill>
+                  <a:schemeClr val="bg1"/>
+                </a:solidFill>
+                <a:latin typeface="Franklin Gothic Medium" panose="020B0603020102020204" charset="0"/>
+                <a:cs typeface="Franklin Gothic Medium" panose="020B0603020102020204" charset="0"/>
+              </a:rPr>
+              <a:t>Прыгун</a:t>
+            </a:r>
+            <a:endParaRPr lang="ru-RU" altLang="en-US">
+              <a:solidFill>
+                <a:schemeClr val="bg1"/>
+              </a:solidFill>
+              <a:latin typeface="Franklin Gothic Medium" panose="020B0603020102020204" charset="0"/>
+              <a:cs typeface="Franklin Gothic Medium" panose="020B0603020102020204" charset="0"/>
+            </a:endParaRPr>
+          </a:p>
+        </p:txBody>
+      </p:sp>
+      <p:sp>
+        <p:nvSpPr>
+          <p:cNvPr id="16" name="Текстовое поле 15"/>
+          <p:cNvSpPr txBox="1"/>
+          <p:nvPr/>
+        </p:nvSpPr>
+        <p:spPr>
+          <a:xfrm>
+            <a:off x="-3997325" y="2764790"/>
+            <a:ext cx="2993390" cy="798830"/>
+          </a:xfrm>
+          <a:prstGeom prst="rect">
+            <a:avLst/>
+          </a:prstGeom>
+          <a:noFill/>
+        </p:spPr>
+        <p:txBody>
+          <a:bodyPr wrap="square" rtlCol="0">
+            <a:spAutoFit/>
+          </a:bodyPr>
+          <a:p>
+            <a:pPr algn="r"/>
+            <a:r>
+              <a:rPr lang="ru-RU" altLang="en-US" sz="2300">
+                <a:solidFill>
+                  <a:schemeClr val="bg1"/>
+                </a:solidFill>
+                <a:latin typeface="Franklin Gothic Medium" panose="020B0603020102020204" charset="0"/>
+                <a:cs typeface="Franklin Gothic Medium" panose="020B0603020102020204" charset="0"/>
+              </a:rPr>
+              <a:t>Описание проиизводительности</a:t>
+            </a:r>
+            <a:endParaRPr lang="ru-RU" altLang="en-US" sz="2300">
+              <a:solidFill>
+                <a:schemeClr val="bg1"/>
+              </a:solidFill>
+              <a:latin typeface="Franklin Gothic Medium" panose="020B0603020102020204" charset="0"/>
+              <a:cs typeface="Franklin Gothic Medium" panose="020B0603020102020204" charset="0"/>
+            </a:endParaRPr>
+          </a:p>
+        </p:txBody>
+      </p:sp>
+      <p:sp>
+        <p:nvSpPr>
+          <p:cNvPr id="17" name="Овал 16"/>
+          <p:cNvSpPr/>
+          <p:nvPr/>
+        </p:nvSpPr>
+        <p:spPr>
+          <a:xfrm>
+            <a:off x="2925445" y="-7881620"/>
+            <a:ext cx="7025640" cy="7025640"/>
+          </a:xfrm>
+          <a:prstGeom prst="ellipse">
+            <a:avLst/>
+          </a:prstGeom>
+          <a:solidFill>
+            <a:srgbClr val="0033B6"/>
+          </a:solidFill>
+          <a:ln>
+            <a:noFill/>
+          </a:ln>
+        </p:spPr>
+        <p:style>
+          <a:lnRef idx="2">
+            <a:schemeClr val="accent1">
+              <a:lumMod val="75000"/>
+            </a:schemeClr>
+          </a:lnRef>
+          <a:fillRef idx="1">
+            <a:schemeClr val="accent1"/>
+          </a:fillRef>
+          <a:effectRef idx="0">
+            <a:srgbClr val="FFFFFF"/>
+          </a:effectRef>
+          <a:fontRef idx="minor">
+            <a:schemeClr val="lt1"/>
+          </a:fontRef>
+        </p:style>
+        <p:txBody>
+          <a:bodyPr rtlCol="0" anchor="ctr"/>
+          <a:p>
+            <a:pPr algn="ctr"/>
+            <a:endParaRPr lang="ru-RU" altLang="en-US"/>
+          </a:p>
+        </p:txBody>
+      </p:sp>
+      <p:sp>
+        <p:nvSpPr>
+          <p:cNvPr id="18" name="Овал 17"/>
+          <p:cNvSpPr/>
+          <p:nvPr/>
+        </p:nvSpPr>
+        <p:spPr>
+          <a:xfrm>
+            <a:off x="11231245" y="-23396575"/>
+            <a:ext cx="2925445" cy="2925445"/>
+          </a:xfrm>
+          <a:prstGeom prst="ellipse">
+            <a:avLst/>
+          </a:prstGeom>
+          <a:solidFill>
+            <a:srgbClr val="315DFF"/>
+          </a:solidFill>
+          <a:ln>
+            <a:noFill/>
+          </a:ln>
+        </p:spPr>
+        <p:style>
+          <a:lnRef idx="2">
+            <a:schemeClr val="accent1">
+              <a:lumMod val="75000"/>
+            </a:schemeClr>
+          </a:lnRef>
+          <a:fillRef idx="1">
+            <a:schemeClr val="accent1"/>
+          </a:fillRef>
+          <a:effectRef idx="0">
+            <a:srgbClr val="FFFFFF"/>
+          </a:effectRef>
+          <a:fontRef idx="minor">
+            <a:schemeClr val="lt1"/>
+          </a:fontRef>
+        </p:style>
+        <p:txBody>
+          <a:bodyPr rtlCol="0" anchor="ctr"/>
+          <a:p>
+            <a:pPr algn="ctr"/>
+            <a:endParaRPr lang="ru-RU" altLang="en-US"/>
+          </a:p>
+        </p:txBody>
+      </p:sp>
+      <p:pic>
+        <p:nvPicPr>
+          <p:cNvPr id="19" name="Изображение 18"/>
+          <p:cNvPicPr>
+            <a:picLocks noChangeAspect="1"/>
+          </p:cNvPicPr>
+          <p:nvPr/>
+        </p:nvPicPr>
+        <p:blipFill>
+          <a:blip r:embed="rId1"/>
+          <a:stretch>
+            <a:fillRect/>
+          </a:stretch>
+        </p:blipFill>
+        <p:spPr>
+          <a:xfrm>
+            <a:off x="133985" y="-5939790"/>
+            <a:ext cx="8317230" cy="3142615"/>
+          </a:xfrm>
+          <a:prstGeom prst="rect">
+            <a:avLst/>
+          </a:prstGeom>
+          <a:ln w="63500">
+            <a:gradFill>
+              <a:gsLst>
+                <a:gs pos="0">
+                  <a:srgbClr val="00A0FC"/>
+                </a:gs>
+                <a:gs pos="100000">
+                  <a:srgbClr val="1B00EA"/>
+                </a:gs>
+              </a:gsLst>
+              <a:lin ang="4740000" scaled="1"/>
+            </a:gradFill>
+          </a:ln>
+        </p:spPr>
+      </p:pic>
+      <p:sp>
+        <p:nvSpPr>
+          <p:cNvPr id="2" name="Овал 1"/>
+          <p:cNvSpPr/>
+          <p:nvPr/>
+        </p:nvSpPr>
+        <p:spPr>
+          <a:xfrm rot="20940000">
+            <a:off x="11662410" y="1649095"/>
+            <a:ext cx="403225" cy="403225"/>
+          </a:xfrm>
+          <a:prstGeom prst="ellipse">
+            <a:avLst/>
+          </a:prstGeom>
+          <a:solidFill>
+            <a:srgbClr val="0072E6"/>
+          </a:solidFill>
+          <a:ln>
+            <a:noFill/>
+          </a:ln>
+        </p:spPr>
+        <p:style>
+          <a:lnRef idx="2">
+            <a:schemeClr val="accent1">
+              <a:lumMod val="75000"/>
+            </a:schemeClr>
+          </a:lnRef>
+          <a:fillRef idx="1">
+            <a:schemeClr val="accent1"/>
+          </a:fillRef>
+          <a:effectRef idx="0">
+            <a:srgbClr val="FFFFFF"/>
+          </a:effectRef>
+          <a:fontRef idx="minor">
+            <a:schemeClr val="lt1"/>
+          </a:fontRef>
+        </p:style>
+        <p:txBody>
+          <a:bodyPr rtlCol="0" anchor="ctr"/>
+          <a:p>
+            <a:pPr algn="ctr"/>
+            <a:endParaRPr lang="ru-RU" altLang="en-US"/>
+          </a:p>
+        </p:txBody>
+      </p:sp>
+      <p:sp>
+        <p:nvSpPr>
+          <p:cNvPr id="6" name="Скругленный прямоугольник 5"/>
+          <p:cNvSpPr/>
+          <p:nvPr/>
+        </p:nvSpPr>
+        <p:spPr>
+          <a:xfrm>
+            <a:off x="664845" y="3429000"/>
+            <a:ext cx="10962640" cy="3913505"/>
+          </a:xfrm>
+          <a:prstGeom prst="roundRect">
+            <a:avLst/>
+          </a:prstGeom>
+          <a:solidFill>
+            <a:srgbClr val="4040B2"/>
+          </a:solidFill>
+          <a:ln w="63500">
+            <a:gradFill>
+              <a:gsLst>
+                <a:gs pos="0">
+                  <a:srgbClr val="00A0FC"/>
+                </a:gs>
+                <a:gs pos="100000">
+                  <a:srgbClr val="1B00EA"/>
+                </a:gs>
+              </a:gsLst>
+              <a:path path="rect">
+                <a:fillToRect l="50000" t="50000" r="50000" b="50000"/>
+              </a:path>
+              <a:tileRect/>
+            </a:gradFill>
+          </a:ln>
+        </p:spPr>
+        <p:style>
+          <a:lnRef idx="2">
+            <a:schemeClr val="accent1">
+              <a:lumMod val="75000"/>
+            </a:schemeClr>
+          </a:lnRef>
+          <a:fillRef idx="1">
+            <a:schemeClr val="accent1"/>
+          </a:fillRef>
+          <a:effectRef idx="0">
+            <a:srgbClr val="FFFFFF"/>
+          </a:effectRef>
+          <a:fontRef idx="minor">
+            <a:schemeClr val="lt1"/>
+          </a:fontRef>
+        </p:style>
+        <p:txBody>
+          <a:bodyPr rtlCol="0" anchor="ctr"/>
+          <a:p>
+            <a:pPr algn="ctr"/>
+            <a:endParaRPr lang="ru-RU" altLang="en-US"/>
+          </a:p>
+        </p:txBody>
+      </p:sp>
+      <p:sp>
+        <p:nvSpPr>
+          <p:cNvPr id="3" name="Овал 2"/>
+          <p:cNvSpPr/>
+          <p:nvPr/>
+        </p:nvSpPr>
+        <p:spPr>
+          <a:xfrm rot="20940000">
+            <a:off x="1767205" y="922020"/>
+            <a:ext cx="403225" cy="403225"/>
+          </a:xfrm>
+          <a:prstGeom prst="ellipse">
+            <a:avLst/>
+          </a:prstGeom>
+          <a:solidFill>
+            <a:srgbClr val="0072E6"/>
+          </a:solidFill>
+          <a:ln>
+            <a:noFill/>
+          </a:ln>
+        </p:spPr>
+        <p:style>
+          <a:lnRef idx="2">
+            <a:schemeClr val="accent1">
+              <a:lumMod val="75000"/>
+            </a:schemeClr>
+          </a:lnRef>
+          <a:fillRef idx="1">
+            <a:schemeClr val="accent1"/>
+          </a:fillRef>
+          <a:effectRef idx="0">
+            <a:srgbClr val="FFFFFF"/>
+          </a:effectRef>
+          <a:fontRef idx="minor">
+            <a:schemeClr val="lt1"/>
+          </a:fontRef>
+        </p:style>
+        <p:txBody>
+          <a:bodyPr rtlCol="0" anchor="ctr"/>
+          <a:p>
+            <a:pPr algn="ctr"/>
+            <a:endParaRPr lang="ru-RU" altLang="en-US"/>
+          </a:p>
+        </p:txBody>
+      </p:sp>
+      <p:sp>
+        <p:nvSpPr>
+          <p:cNvPr id="4" name="Овал 3"/>
+          <p:cNvSpPr/>
+          <p:nvPr/>
+        </p:nvSpPr>
+        <p:spPr>
+          <a:xfrm rot="20940000">
+            <a:off x="1096010" y="2490470"/>
+            <a:ext cx="501650" cy="501650"/>
+          </a:xfrm>
+          <a:prstGeom prst="ellipse">
+            <a:avLst/>
+          </a:prstGeom>
+          <a:solidFill>
+            <a:srgbClr val="0041E6"/>
+          </a:solidFill>
+          <a:ln>
+            <a:noFill/>
+          </a:ln>
+        </p:spPr>
+        <p:style>
+          <a:lnRef idx="2">
+            <a:schemeClr val="accent1">
+              <a:lumMod val="75000"/>
+            </a:schemeClr>
+          </a:lnRef>
+          <a:fillRef idx="1">
+            <a:schemeClr val="accent1"/>
+          </a:fillRef>
+          <a:effectRef idx="0">
+            <a:srgbClr val="FFFFFF"/>
+          </a:effectRef>
+          <a:fontRef idx="minor">
+            <a:schemeClr val="lt1"/>
+          </a:fontRef>
+        </p:style>
+        <p:txBody>
+          <a:bodyPr rtlCol="0" anchor="ctr"/>
+          <a:p>
+            <a:pPr algn="ctr"/>
+            <a:endParaRPr lang="ru-RU" altLang="en-US"/>
+          </a:p>
+        </p:txBody>
+      </p:sp>
+      <p:sp>
+        <p:nvSpPr>
+          <p:cNvPr id="15" name="Овал 14"/>
+          <p:cNvSpPr/>
+          <p:nvPr/>
+        </p:nvSpPr>
+        <p:spPr>
+          <a:xfrm rot="20940000">
+            <a:off x="9144000" y="43180"/>
+            <a:ext cx="501650" cy="501650"/>
+          </a:xfrm>
+          <a:prstGeom prst="ellipse">
+            <a:avLst/>
+          </a:prstGeom>
+          <a:solidFill>
+            <a:srgbClr val="0041E6"/>
+          </a:solidFill>
+          <a:ln>
+            <a:noFill/>
+          </a:ln>
+        </p:spPr>
+        <p:style>
+          <a:lnRef idx="2">
+            <a:schemeClr val="accent1">
+              <a:lumMod val="75000"/>
+            </a:schemeClr>
+          </a:lnRef>
+          <a:fillRef idx="1">
+            <a:schemeClr val="accent1"/>
+          </a:fillRef>
+          <a:effectRef idx="0">
+            <a:srgbClr val="FFFFFF"/>
+          </a:effectRef>
+          <a:fontRef idx="minor">
+            <a:schemeClr val="lt1"/>
+          </a:fontRef>
+        </p:style>
+        <p:txBody>
+          <a:bodyPr rtlCol="0" anchor="ctr"/>
+          <a:p>
+            <a:pPr algn="ctr"/>
+            <a:endParaRPr lang="ru-RU" altLang="en-US"/>
+          </a:p>
+        </p:txBody>
+      </p:sp>
+      <p:sp>
+        <p:nvSpPr>
+          <p:cNvPr id="5" name="Текстовое поле 4"/>
+          <p:cNvSpPr txBox="1"/>
+          <p:nvPr/>
+        </p:nvSpPr>
+        <p:spPr>
+          <a:xfrm>
+            <a:off x="3049270" y="3690620"/>
+            <a:ext cx="6193155" cy="706755"/>
+          </a:xfrm>
+          <a:prstGeom prst="rect">
+            <a:avLst/>
+          </a:prstGeom>
+          <a:noFill/>
+        </p:spPr>
+        <p:txBody>
+          <a:bodyPr wrap="square" rtlCol="0">
+            <a:spAutoFit/>
+          </a:bodyPr>
+          <a:p>
+            <a:pPr algn="ctr"/>
+            <a:r>
+              <a:rPr lang="ru-RU" altLang="en-US" sz="4000">
+                <a:solidFill>
+                  <a:schemeClr val="bg1"/>
+                </a:solidFill>
+                <a:latin typeface="Franklin Gothic Medium" panose="020B0603020102020204" charset="0"/>
+                <a:cs typeface="Franklin Gothic Medium" panose="020B0603020102020204" charset="0"/>
+              </a:rPr>
+              <a:t>Спасибо за внимание</a:t>
+            </a:r>
+            <a:endParaRPr lang="ru-RU" altLang="en-US" sz="4000">
+              <a:solidFill>
+                <a:schemeClr val="bg1"/>
+              </a:solidFill>
+              <a:latin typeface="Franklin Gothic Medium" panose="020B0603020102020204" charset="0"/>
+              <a:cs typeface="Franklin Gothic Medium" panose="020B0603020102020204" charset="0"/>
+            </a:endParaRPr>
+          </a:p>
+        </p:txBody>
+      </p:sp>
+      <p:pic>
+        <p:nvPicPr>
+          <p:cNvPr id="20" name="Изображение 19" descr="MyLogo"/>
+          <p:cNvPicPr>
+            <a:picLocks noChangeAspect="1"/>
+          </p:cNvPicPr>
+          <p:nvPr/>
+        </p:nvPicPr>
+        <p:blipFill>
+          <a:blip r:embed="rId2"/>
+          <a:stretch>
+            <a:fillRect/>
+          </a:stretch>
+        </p:blipFill>
+        <p:spPr>
+          <a:xfrm>
+            <a:off x="4502150" y="114935"/>
+            <a:ext cx="3187700" cy="3187700"/>
+          </a:xfrm>
+          <a:prstGeom prst="rect">
+            <a:avLst/>
+          </a:prstGeom>
+        </p:spPr>
+      </p:pic>
     </p:spTree>
   </p:cSld>
   <p:clrMapOvr>

</xml_diff>